<commit_message>
Apply Altimetrik branding to presentation decks
Update presentation file titles and metadata to reflect Altimetrik branding.

Replit-Commit-Author: Agent
Replit-Commit-Session-Id: 360d001d-31ce-437b-b465-6101ff553b51
Replit-Commit-Checkpoint-Type: full_checkpoint
Replit-Commit-Event-Id: 1ba94846-b994-4322-a274-c9886fd9ce87
Replit-Commit-Screenshot-Url: https://storage.googleapis.com/screenshot-production-us-central1/bf12eced-1d8a-40ea-bb6a-2c14f015c791/360d001d-31ce-437b-b465-6101ff553b51/xEHiIqw
Replit-Helium-Checkpoint-Created: true
</commit_message>
<xml_diff>
--- a/attached_assets/DealPad_10min_PS_Demo.pptx
+++ b/attached_assets/DealPad_10min_PS_Demo.pptx
@@ -3115,7 +3115,7 @@
             <a:avLst/>
           </a:prstGeom>
           <a:solidFill>
-            <a:srgbClr val="0B1F3A"/>
+            <a:srgbClr val="111418"/>
           </a:solidFill>
           <a:ln>
             <a:noFill/>
@@ -3159,7 +3159,7 @@
             <a:avLst/>
           </a:prstGeom>
           <a:solidFill>
-            <a:srgbClr val="6D28D9"/>
+            <a:srgbClr val="F26522"/>
           </a:solidFill>
           <a:ln>
             <a:noFill/>
@@ -3190,176 +3190,20 @@
       </p:sp>
       <p:sp>
         <p:nvSpPr>
-          <p:cNvPr id="4" name="TextBox 3"/>
-          <p:cNvSpPr txBox="1"/>
-          <p:nvPr/>
-        </p:nvSpPr>
-        <p:spPr>
-          <a:xfrm>
-            <a:off x="502920" y="457200"/>
-            <a:ext cx="3657600" cy="320040"/>
-          </a:xfrm>
-          <a:prstGeom prst="rect">
-            <a:avLst/>
-          </a:prstGeom>
-          <a:noFill/>
-        </p:spPr>
-        <p:txBody>
-          <a:bodyPr wrap="square" lIns="0" rIns="0" tIns="0" bIns="0" anchor="t">
-            <a:spAutoFit/>
-          </a:bodyPr>
-          <a:lstStyle/>
-          <a:p>
-            <a:pPr algn="l">
-              <a:spcAft>
-                <a:spcPts val="0"/>
-              </a:spcAft>
-            </a:pPr>
-            <a:r>
-              <a:rPr sz="1100" b="1">
-                <a:solidFill>
-                  <a:srgbClr val="C4B5FD"/>
-                </a:solidFill>
-                <a:latin typeface="Calibri"/>
-              </a:rPr>
-              <a:t>ARMANINO LLP</a:t>
-            </a:r>
-          </a:p>
-        </p:txBody>
-      </p:sp>
-      <p:sp>
-        <p:nvSpPr>
-          <p:cNvPr id="5" name="TextBox 4"/>
-          <p:cNvSpPr txBox="1"/>
-          <p:nvPr/>
-        </p:nvSpPr>
-        <p:spPr>
-          <a:xfrm>
-            <a:off x="502920" y="868680"/>
-            <a:ext cx="3657600" cy="320040"/>
-          </a:xfrm>
-          <a:prstGeom prst="rect">
-            <a:avLst/>
-          </a:prstGeom>
-          <a:noFill/>
-        </p:spPr>
-        <p:txBody>
-          <a:bodyPr wrap="square" lIns="0" rIns="0" tIns="0" bIns="0" anchor="t">
-            <a:spAutoFit/>
-          </a:bodyPr>
-          <a:lstStyle/>
-          <a:p>
-            <a:pPr algn="l">
-              <a:spcAft>
-                <a:spcPts val="0"/>
-              </a:spcAft>
-            </a:pPr>
-            <a:r>
-              <a:rPr sz="1100" b="0">
-                <a:solidFill>
-                  <a:srgbClr val="C4B5FD"/>
-                </a:solidFill>
-                <a:latin typeface="Calibri"/>
-              </a:rPr>
-              <a:t>Solutioning workshop</a:t>
-            </a:r>
-          </a:p>
-        </p:txBody>
-      </p:sp>
-      <p:sp>
-        <p:nvSpPr>
-          <p:cNvPr id="6" name="TextBox 5"/>
-          <p:cNvSpPr txBox="1"/>
-          <p:nvPr/>
-        </p:nvSpPr>
-        <p:spPr>
-          <a:xfrm>
-            <a:off x="502920" y="2194560"/>
-            <a:ext cx="3657600" cy="1097280"/>
-          </a:xfrm>
-          <a:prstGeom prst="rect">
-            <a:avLst/>
-          </a:prstGeom>
-          <a:noFill/>
-        </p:spPr>
-        <p:txBody>
-          <a:bodyPr wrap="square" lIns="0" rIns="0" tIns="0" bIns="0" anchor="t">
-            <a:spAutoFit/>
-          </a:bodyPr>
-          <a:lstStyle/>
-          <a:p>
-            <a:pPr algn="l">
-              <a:spcAft>
-                <a:spcPts val="0"/>
-              </a:spcAft>
-            </a:pPr>
-            <a:r>
-              <a:rPr sz="5400" b="1">
-                <a:solidFill>
-                  <a:srgbClr val="FFFFFF"/>
-                </a:solidFill>
-                <a:latin typeface="Calibri"/>
-              </a:rPr>
-              <a:t>DealPad</a:t>
-            </a:r>
-          </a:p>
-        </p:txBody>
-      </p:sp>
-      <p:sp>
-        <p:nvSpPr>
-          <p:cNvPr id="7" name="TextBox 6"/>
-          <p:cNvSpPr txBox="1"/>
-          <p:nvPr/>
-        </p:nvSpPr>
-        <p:spPr>
-          <a:xfrm>
-            <a:off x="502920" y="3108960"/>
-            <a:ext cx="3657600" cy="548640"/>
-          </a:xfrm>
-          <a:prstGeom prst="rect">
-            <a:avLst/>
-          </a:prstGeom>
-          <a:noFill/>
-        </p:spPr>
-        <p:txBody>
-          <a:bodyPr wrap="square" lIns="0" rIns="0" tIns="0" bIns="0" anchor="t">
-            <a:spAutoFit/>
-          </a:bodyPr>
-          <a:lstStyle/>
-          <a:p>
-            <a:pPr algn="l">
-              <a:spcAft>
-                <a:spcPts val="0"/>
-              </a:spcAft>
-            </a:pPr>
-            <a:r>
-              <a:rPr sz="1800" b="0">
-                <a:solidFill>
-                  <a:srgbClr val="E9D5FF"/>
-                </a:solidFill>
-                <a:latin typeface="Calibri"/>
-              </a:rPr>
-              <a:t>NextGenApp Pricing &amp; Scoping 2.0</a:t>
-            </a:r>
-          </a:p>
-        </p:txBody>
-      </p:sp>
-      <p:sp>
-        <p:nvSpPr>
-          <p:cNvPr id="8" name="Rectangle 7"/>
+          <p:cNvPr id="4" name="Oval 3"/>
           <p:cNvSpPr/>
           <p:nvPr/>
         </p:nvSpPr>
         <p:spPr>
           <a:xfrm>
-            <a:off x="502920" y="3703320"/>
-            <a:ext cx="731520" cy="28575"/>
-          </a:xfrm>
-          <a:prstGeom prst="rect">
+            <a:off x="502920" y="502920"/>
+            <a:ext cx="329184" cy="329184"/>
+          </a:xfrm>
+          <a:prstGeom prst="ellipse">
             <a:avLst/>
           </a:prstGeom>
           <a:solidFill>
-            <a:srgbClr val="6D28D9"/>
+            <a:srgbClr val="F26522"/>
           </a:solidFill>
           <a:ln>
             <a:noFill/>
@@ -3390,14 +3234,53 @@
       </p:sp>
       <p:sp>
         <p:nvSpPr>
-          <p:cNvPr id="9" name="TextBox 8"/>
-          <p:cNvSpPr txBox="1"/>
-          <p:nvPr/>
-        </p:nvSpPr>
-        <p:spPr>
-          <a:xfrm>
-            <a:off x="502920" y="3840480"/>
-            <a:ext cx="3657600" cy="457200"/>
+          <p:cNvPr id="5" name="TextBox 4"/>
+          <p:cNvSpPr txBox="1"/>
+          <p:nvPr/>
+        </p:nvSpPr>
+        <p:spPr>
+          <a:xfrm>
+            <a:off x="960120" y="502920"/>
+            <a:ext cx="3200400" cy="329184"/>
+          </a:xfrm>
+          <a:prstGeom prst="rect">
+            <a:avLst/>
+          </a:prstGeom>
+          <a:noFill/>
+        </p:spPr>
+        <p:txBody>
+          <a:bodyPr wrap="square" lIns="0" rIns="0" tIns="0" bIns="0" anchor="ctr">
+            <a:spAutoFit/>
+          </a:bodyPr>
+          <a:lstStyle/>
+          <a:p>
+            <a:pPr algn="l">
+              <a:spcAft>
+                <a:spcPts val="0"/>
+              </a:spcAft>
+            </a:pPr>
+            <a:r>
+              <a:rPr sz="1200" b="1">
+                <a:solidFill>
+                  <a:srgbClr val="FFFFFF"/>
+                </a:solidFill>
+                <a:latin typeface="Calibri"/>
+              </a:rPr>
+              <a:t>ALTIMETRIK</a:t>
+            </a:r>
+          </a:p>
+        </p:txBody>
+      </p:sp>
+      <p:sp>
+        <p:nvSpPr>
+          <p:cNvPr id="6" name="TextBox 5"/>
+          <p:cNvSpPr txBox="1"/>
+          <p:nvPr/>
+        </p:nvSpPr>
+        <p:spPr>
+          <a:xfrm>
+            <a:off x="502920" y="1051560"/>
+            <a:ext cx="3657600" cy="320040"/>
           </a:xfrm>
           <a:prstGeom prst="rect">
             <a:avLst/>
@@ -3416,27 +3299,66 @@
               </a:spcAft>
             </a:pPr>
             <a:r>
-              <a:rPr sz="1400" b="0">
+              <a:rPr sz="1000" b="0">
+                <a:solidFill>
+                  <a:srgbClr val="FFD9B8"/>
+                </a:solidFill>
+                <a:latin typeface="Calibri"/>
+              </a:rPr>
+              <a:t>for Armanino LLP — Solutioning workshop</a:t>
+            </a:r>
+          </a:p>
+        </p:txBody>
+      </p:sp>
+      <p:sp>
+        <p:nvSpPr>
+          <p:cNvPr id="7" name="TextBox 6"/>
+          <p:cNvSpPr txBox="1"/>
+          <p:nvPr/>
+        </p:nvSpPr>
+        <p:spPr>
+          <a:xfrm>
+            <a:off x="502920" y="2194560"/>
+            <a:ext cx="3657600" cy="1097280"/>
+          </a:xfrm>
+          <a:prstGeom prst="rect">
+            <a:avLst/>
+          </a:prstGeom>
+          <a:noFill/>
+        </p:spPr>
+        <p:txBody>
+          <a:bodyPr wrap="square" lIns="0" rIns="0" tIns="0" bIns="0" anchor="t">
+            <a:spAutoFit/>
+          </a:bodyPr>
+          <a:lstStyle/>
+          <a:p>
+            <a:pPr algn="l">
+              <a:spcAft>
+                <a:spcPts val="0"/>
+              </a:spcAft>
+            </a:pPr>
+            <a:r>
+              <a:rPr sz="5400" b="1">
                 <a:solidFill>
                   <a:srgbClr val="FFFFFF"/>
                 </a:solidFill>
                 <a:latin typeface="Calibri"/>
               </a:rPr>
-              <a:t>10-minute stakeholder demo</a:t>
-            </a:r>
-          </a:p>
-        </p:txBody>
-      </p:sp>
-      <p:sp>
-        <p:nvSpPr>
-          <p:cNvPr id="10" name="TextBox 9"/>
-          <p:cNvSpPr txBox="1"/>
-          <p:nvPr/>
-        </p:nvSpPr>
-        <p:spPr>
-          <a:xfrm>
-            <a:off x="502920" y="4160520"/>
-            <a:ext cx="3657600" cy="457200"/>
+              <a:t>DealPad</a:t>
+            </a:r>
+          </a:p>
+        </p:txBody>
+      </p:sp>
+      <p:sp>
+        <p:nvSpPr>
+          <p:cNvPr id="8" name="TextBox 7"/>
+          <p:cNvSpPr txBox="1"/>
+          <p:nvPr/>
+        </p:nvSpPr>
+        <p:spPr>
+          <a:xfrm>
+            <a:off x="502920" y="3108960"/>
+            <a:ext cx="3657600" cy="548640"/>
           </a:xfrm>
           <a:prstGeom prst="rect">
             <a:avLst/>
@@ -3455,157 +3377,36 @@
               </a:spcAft>
             </a:pPr>
             <a:r>
-              <a:rPr sz="1200" b="0">
-                <a:solidFill>
-                  <a:srgbClr val="C4B5FD"/>
-                </a:solidFill>
-                <a:latin typeface="Calibri"/>
-              </a:rPr>
-              <a:t>Product &amp; Solutioning audience</a:t>
-            </a:r>
-          </a:p>
-        </p:txBody>
-      </p:sp>
-      <p:sp>
-        <p:nvSpPr>
-          <p:cNvPr id="11" name="TextBox 10"/>
-          <p:cNvSpPr txBox="1"/>
-          <p:nvPr/>
-        </p:nvSpPr>
-        <p:spPr>
-          <a:xfrm>
-            <a:off x="502920" y="6263640"/>
-            <a:ext cx="3657600" cy="365760"/>
-          </a:xfrm>
-          <a:prstGeom prst="rect">
-            <a:avLst/>
-          </a:prstGeom>
-          <a:noFill/>
-        </p:spPr>
-        <p:txBody>
-          <a:bodyPr wrap="square" lIns="0" rIns="0" tIns="0" bIns="0" anchor="t">
-            <a:spAutoFit/>
-          </a:bodyPr>
-          <a:lstStyle/>
-          <a:p>
-            <a:pPr algn="l">
-              <a:spcAft>
-                <a:spcPts val="0"/>
-              </a:spcAft>
-            </a:pPr>
-            <a:r>
-              <a:rPr sz="1000" b="0">
-                <a:solidFill>
-                  <a:srgbClr val="94A3B8"/>
-                </a:solidFill>
-                <a:latin typeface="Calibri"/>
-              </a:rPr>
-              <a:t>Working session — for discussion</a:t>
-            </a:r>
-          </a:p>
-        </p:txBody>
-      </p:sp>
-      <p:sp>
-        <p:nvSpPr>
-          <p:cNvPr id="12" name="TextBox 11"/>
-          <p:cNvSpPr txBox="1"/>
-          <p:nvPr/>
-        </p:nvSpPr>
-        <p:spPr>
-          <a:xfrm>
-            <a:off x="4663440" y="822960"/>
-            <a:ext cx="6949440" cy="365760"/>
-          </a:xfrm>
-          <a:prstGeom prst="rect">
-            <a:avLst/>
-          </a:prstGeom>
-          <a:noFill/>
-        </p:spPr>
-        <p:txBody>
-          <a:bodyPr wrap="square" lIns="0" rIns="0" tIns="0" bIns="0" anchor="t">
-            <a:spAutoFit/>
-          </a:bodyPr>
-          <a:lstStyle/>
-          <a:p>
-            <a:pPr algn="l">
-              <a:spcAft>
-                <a:spcPts val="0"/>
-              </a:spcAft>
-            </a:pPr>
-            <a:r>
-              <a:rPr sz="1000" b="1">
-                <a:solidFill>
-                  <a:srgbClr val="6D28D9"/>
-                </a:solidFill>
-                <a:latin typeface="Calibri"/>
-              </a:rPr>
-              <a:t>WHAT YOU'LL SEE</a:t>
-            </a:r>
-          </a:p>
-        </p:txBody>
-      </p:sp>
-      <p:sp>
-        <p:nvSpPr>
-          <p:cNvPr id="13" name="TextBox 12"/>
-          <p:cNvSpPr txBox="1"/>
-          <p:nvPr/>
-        </p:nvSpPr>
-        <p:spPr>
-          <a:xfrm>
-            <a:off x="4663440" y="1097280"/>
-            <a:ext cx="6949440" cy="1828800"/>
-          </a:xfrm>
-          <a:prstGeom prst="rect">
-            <a:avLst/>
-          </a:prstGeom>
-          <a:noFill/>
-        </p:spPr>
-        <p:txBody>
-          <a:bodyPr wrap="square" lIns="0" rIns="0" tIns="0" bIns="0" anchor="t">
-            <a:spAutoFit/>
-          </a:bodyPr>
-          <a:lstStyle/>
-          <a:p>
-            <a:pPr algn="l">
-              <a:spcAft>
-                <a:spcPts val="0"/>
-              </a:spcAft>
-            </a:pPr>
-            <a:r>
-              <a:rPr sz="1600" b="0">
-                <a:solidFill>
-                  <a:srgbClr val="1F2937"/>
-                </a:solidFill>
-                <a:latin typeface="Calibri"/>
-              </a:rPr>
-              <a:t>A working pricing &amp; scoping platform engineered for Armanino's deal motion — intake to approval to outbound, with AI grounded in our own historical data and an integration fabric that treats Dynamics, Workday, Intapp and Conga as first-class peers, not bolt-ons.</a:t>
-            </a:r>
-          </a:p>
-        </p:txBody>
-      </p:sp>
-      <p:sp>
-        <p:nvSpPr>
-          <p:cNvPr id="14" name="Rounded Rectangle 13"/>
+              <a:rPr sz="1800" b="0">
+                <a:solidFill>
+                  <a:srgbClr val="FFD9B8"/>
+                </a:solidFill>
+                <a:latin typeface="Calibri"/>
+              </a:rPr>
+              <a:t>NextGenApp Pricing &amp; Scoping 2.0</a:t>
+            </a:r>
+          </a:p>
+        </p:txBody>
+      </p:sp>
+      <p:sp>
+        <p:nvSpPr>
+          <p:cNvPr id="9" name="Rectangle 8"/>
           <p:cNvSpPr/>
           <p:nvPr/>
         </p:nvSpPr>
         <p:spPr>
           <a:xfrm>
-            <a:off x="4663440" y="3657600"/>
-            <a:ext cx="2286000" cy="2194560"/>
-          </a:xfrm>
-          <a:prstGeom prst="roundRect">
-            <a:avLst>
-              <a:gd name="adj" fmla="val 8000"/>
-            </a:avLst>
+            <a:off x="502920" y="3703320"/>
+            <a:ext cx="731520" cy="28575"/>
+          </a:xfrm>
+          <a:prstGeom prst="rect">
+            <a:avLst/>
           </a:prstGeom>
           <a:solidFill>
-            <a:srgbClr val="F7F9FC"/>
+            <a:srgbClr val="F26522"/>
           </a:solidFill>
           <a:ln>
-            <a:solidFill>
-              <a:srgbClr val="E2E8F0"/>
-            </a:solidFill>
+            <a:noFill/>
           </a:ln>
           <a:effectLst/>
         </p:spPr>
@@ -3633,7 +3434,250 @@
       </p:sp>
       <p:sp>
         <p:nvSpPr>
-          <p:cNvPr id="15" name="Rectangle 14"/>
+          <p:cNvPr id="10" name="TextBox 9"/>
+          <p:cNvSpPr txBox="1"/>
+          <p:nvPr/>
+        </p:nvSpPr>
+        <p:spPr>
+          <a:xfrm>
+            <a:off x="502920" y="3840480"/>
+            <a:ext cx="3657600" cy="457200"/>
+          </a:xfrm>
+          <a:prstGeom prst="rect">
+            <a:avLst/>
+          </a:prstGeom>
+          <a:noFill/>
+        </p:spPr>
+        <p:txBody>
+          <a:bodyPr wrap="square" lIns="0" rIns="0" tIns="0" bIns="0" anchor="t">
+            <a:spAutoFit/>
+          </a:bodyPr>
+          <a:lstStyle/>
+          <a:p>
+            <a:pPr algn="l">
+              <a:spcAft>
+                <a:spcPts val="0"/>
+              </a:spcAft>
+            </a:pPr>
+            <a:r>
+              <a:rPr sz="1400" b="0">
+                <a:solidFill>
+                  <a:srgbClr val="FFFFFF"/>
+                </a:solidFill>
+                <a:latin typeface="Calibri"/>
+              </a:rPr>
+              <a:t>10-minute stakeholder demo</a:t>
+            </a:r>
+          </a:p>
+        </p:txBody>
+      </p:sp>
+      <p:sp>
+        <p:nvSpPr>
+          <p:cNvPr id="11" name="TextBox 10"/>
+          <p:cNvSpPr txBox="1"/>
+          <p:nvPr/>
+        </p:nvSpPr>
+        <p:spPr>
+          <a:xfrm>
+            <a:off x="502920" y="4160520"/>
+            <a:ext cx="3657600" cy="457200"/>
+          </a:xfrm>
+          <a:prstGeom prst="rect">
+            <a:avLst/>
+          </a:prstGeom>
+          <a:noFill/>
+        </p:spPr>
+        <p:txBody>
+          <a:bodyPr wrap="square" lIns="0" rIns="0" tIns="0" bIns="0" anchor="t">
+            <a:spAutoFit/>
+          </a:bodyPr>
+          <a:lstStyle/>
+          <a:p>
+            <a:pPr algn="l">
+              <a:spcAft>
+                <a:spcPts val="0"/>
+              </a:spcAft>
+            </a:pPr>
+            <a:r>
+              <a:rPr sz="1200" b="0">
+                <a:solidFill>
+                  <a:srgbClr val="FFC299"/>
+                </a:solidFill>
+                <a:latin typeface="Calibri"/>
+              </a:rPr>
+              <a:t>Product &amp; Solutioning audience</a:t>
+            </a:r>
+          </a:p>
+        </p:txBody>
+      </p:sp>
+      <p:sp>
+        <p:nvSpPr>
+          <p:cNvPr id="12" name="TextBox 11"/>
+          <p:cNvSpPr txBox="1"/>
+          <p:nvPr/>
+        </p:nvSpPr>
+        <p:spPr>
+          <a:xfrm>
+            <a:off x="502920" y="6263640"/>
+            <a:ext cx="3657600" cy="365760"/>
+          </a:xfrm>
+          <a:prstGeom prst="rect">
+            <a:avLst/>
+          </a:prstGeom>
+          <a:noFill/>
+        </p:spPr>
+        <p:txBody>
+          <a:bodyPr wrap="square" lIns="0" rIns="0" tIns="0" bIns="0" anchor="t">
+            <a:spAutoFit/>
+          </a:bodyPr>
+          <a:lstStyle/>
+          <a:p>
+            <a:pPr algn="l">
+              <a:spcAft>
+                <a:spcPts val="0"/>
+              </a:spcAft>
+            </a:pPr>
+            <a:r>
+              <a:rPr sz="1000" b="0">
+                <a:solidFill>
+                  <a:srgbClr val="B0B0B6"/>
+                </a:solidFill>
+                <a:latin typeface="Calibri"/>
+              </a:rPr>
+              <a:t>Working session — for discussion</a:t>
+            </a:r>
+          </a:p>
+        </p:txBody>
+      </p:sp>
+      <p:sp>
+        <p:nvSpPr>
+          <p:cNvPr id="13" name="TextBox 12"/>
+          <p:cNvSpPr txBox="1"/>
+          <p:nvPr/>
+        </p:nvSpPr>
+        <p:spPr>
+          <a:xfrm>
+            <a:off x="4663440" y="822960"/>
+            <a:ext cx="6949440" cy="365760"/>
+          </a:xfrm>
+          <a:prstGeom prst="rect">
+            <a:avLst/>
+          </a:prstGeom>
+          <a:noFill/>
+        </p:spPr>
+        <p:txBody>
+          <a:bodyPr wrap="square" lIns="0" rIns="0" tIns="0" bIns="0" anchor="t">
+            <a:spAutoFit/>
+          </a:bodyPr>
+          <a:lstStyle/>
+          <a:p>
+            <a:pPr algn="l">
+              <a:spcAft>
+                <a:spcPts val="0"/>
+              </a:spcAft>
+            </a:pPr>
+            <a:r>
+              <a:rPr sz="1000" b="1">
+                <a:solidFill>
+                  <a:srgbClr val="F26522"/>
+                </a:solidFill>
+                <a:latin typeface="Calibri"/>
+              </a:rPr>
+              <a:t>WHAT YOU'LL SEE</a:t>
+            </a:r>
+          </a:p>
+        </p:txBody>
+      </p:sp>
+      <p:sp>
+        <p:nvSpPr>
+          <p:cNvPr id="14" name="TextBox 13"/>
+          <p:cNvSpPr txBox="1"/>
+          <p:nvPr/>
+        </p:nvSpPr>
+        <p:spPr>
+          <a:xfrm>
+            <a:off x="4663440" y="1097280"/>
+            <a:ext cx="6949440" cy="1828800"/>
+          </a:xfrm>
+          <a:prstGeom prst="rect">
+            <a:avLst/>
+          </a:prstGeom>
+          <a:noFill/>
+        </p:spPr>
+        <p:txBody>
+          <a:bodyPr wrap="square" lIns="0" rIns="0" tIns="0" bIns="0" anchor="t">
+            <a:spAutoFit/>
+          </a:bodyPr>
+          <a:lstStyle/>
+          <a:p>
+            <a:pPr algn="l">
+              <a:spcAft>
+                <a:spcPts val="0"/>
+              </a:spcAft>
+            </a:pPr>
+            <a:r>
+              <a:rPr sz="1600" b="0">
+                <a:solidFill>
+                  <a:srgbClr val="1F242C"/>
+                </a:solidFill>
+                <a:latin typeface="Calibri"/>
+              </a:rPr>
+              <a:t>A working pricing &amp; scoping platform engineered for Armanino's deal motion — intake to approval to outbound, with AI grounded in our own historical data and an integration fabric that treats Dynamics, Workday, Intapp and Conga as first-class peers, not bolt-ons.</a:t>
+            </a:r>
+          </a:p>
+        </p:txBody>
+      </p:sp>
+      <p:sp>
+        <p:nvSpPr>
+          <p:cNvPr id="15" name="Rounded Rectangle 14"/>
+          <p:cNvSpPr/>
+          <p:nvPr/>
+        </p:nvSpPr>
+        <p:spPr>
+          <a:xfrm>
+            <a:off x="4663440" y="3657600"/>
+            <a:ext cx="2286000" cy="2194560"/>
+          </a:xfrm>
+          <a:prstGeom prst="roundRect">
+            <a:avLst>
+              <a:gd name="adj" fmla="val 8000"/>
+            </a:avLst>
+          </a:prstGeom>
+          <a:solidFill>
+            <a:srgbClr val="F7F7F8"/>
+          </a:solidFill>
+          <a:ln>
+            <a:solidFill>
+              <a:srgbClr val="E3E6EB"/>
+            </a:solidFill>
+          </a:ln>
+          <a:effectLst/>
+        </p:spPr>
+        <p:style>
+          <a:lnRef idx="1">
+            <a:schemeClr val="accent1"/>
+          </a:lnRef>
+          <a:fillRef idx="3">
+            <a:schemeClr val="accent1"/>
+          </a:fillRef>
+          <a:effectRef idx="2">
+            <a:schemeClr val="accent1"/>
+          </a:effectRef>
+          <a:fontRef idx="minor">
+            <a:schemeClr val="lt1"/>
+          </a:fontRef>
+        </p:style>
+        <p:txBody>
+          <a:bodyPr rtlCol="0" anchor="ctr"/>
+          <a:lstStyle/>
+          <a:p>
+            <a:pPr algn="ctr"/>
+          </a:p>
+        </p:txBody>
+      </p:sp>
+      <p:sp>
+        <p:nvSpPr>
+          <p:cNvPr id="16" name="Rectangle 15"/>
           <p:cNvSpPr/>
           <p:nvPr/>
         </p:nvSpPr>
@@ -3646,7 +3690,7 @@
             <a:avLst/>
           </a:prstGeom>
           <a:solidFill>
-            <a:srgbClr val="6D28D9"/>
+            <a:srgbClr val="F26522"/>
           </a:solidFill>
           <a:ln>
             <a:noFill/>
@@ -3677,7 +3721,7 @@
       </p:sp>
       <p:sp>
         <p:nvSpPr>
-          <p:cNvPr id="16" name="TextBox 15"/>
+          <p:cNvPr id="17" name="TextBox 16"/>
           <p:cNvSpPr txBox="1"/>
           <p:nvPr/>
         </p:nvSpPr>
@@ -3705,7 +3749,7 @@
             <a:r>
               <a:rPr sz="1400" b="1">
                 <a:solidFill>
-                  <a:srgbClr val="0B1F3A"/>
+                  <a:srgbClr val="111418"/>
                 </a:solidFill>
                 <a:latin typeface="Calibri"/>
               </a:rPr>
@@ -3716,7 +3760,7 @@
       </p:sp>
       <p:sp>
         <p:nvSpPr>
-          <p:cNvPr id="17" name="TextBox 16"/>
+          <p:cNvPr id="18" name="TextBox 17"/>
           <p:cNvSpPr txBox="1"/>
           <p:nvPr/>
         </p:nvSpPr>
@@ -3755,7 +3799,7 @@
       </p:sp>
       <p:sp>
         <p:nvSpPr>
-          <p:cNvPr id="18" name="Rounded Rectangle 17"/>
+          <p:cNvPr id="19" name="Rounded Rectangle 18"/>
           <p:cNvSpPr/>
           <p:nvPr/>
         </p:nvSpPr>
@@ -3770,11 +3814,11 @@
             </a:avLst>
           </a:prstGeom>
           <a:solidFill>
-            <a:srgbClr val="F7F9FC"/>
+            <a:srgbClr val="F7F7F8"/>
           </a:solidFill>
           <a:ln>
             <a:solidFill>
-              <a:srgbClr val="E2E8F0"/>
+              <a:srgbClr val="E3E6EB"/>
             </a:solidFill>
           </a:ln>
           <a:effectLst/>
@@ -3803,7 +3847,7 @@
       </p:sp>
       <p:sp>
         <p:nvSpPr>
-          <p:cNvPr id="19" name="Rectangle 18"/>
+          <p:cNvPr id="20" name="Rectangle 19"/>
           <p:cNvSpPr/>
           <p:nvPr/>
         </p:nvSpPr>
@@ -3816,7 +3860,7 @@
             <a:avLst/>
           </a:prstGeom>
           <a:solidFill>
-            <a:srgbClr val="6D28D9"/>
+            <a:srgbClr val="F26522"/>
           </a:solidFill>
           <a:ln>
             <a:noFill/>
@@ -3847,7 +3891,7 @@
       </p:sp>
       <p:sp>
         <p:nvSpPr>
-          <p:cNvPr id="20" name="TextBox 19"/>
+          <p:cNvPr id="21" name="TextBox 20"/>
           <p:cNvSpPr txBox="1"/>
           <p:nvPr/>
         </p:nvSpPr>
@@ -3875,7 +3919,7 @@
             <a:r>
               <a:rPr sz="1400" b="1">
                 <a:solidFill>
-                  <a:srgbClr val="0B1F3A"/>
+                  <a:srgbClr val="111418"/>
                 </a:solidFill>
                 <a:latin typeface="Calibri"/>
               </a:rPr>
@@ -3886,7 +3930,7 @@
       </p:sp>
       <p:sp>
         <p:nvSpPr>
-          <p:cNvPr id="21" name="TextBox 20"/>
+          <p:cNvPr id="22" name="TextBox 21"/>
           <p:cNvSpPr txBox="1"/>
           <p:nvPr/>
         </p:nvSpPr>
@@ -3925,7 +3969,7 @@
       </p:sp>
       <p:sp>
         <p:nvSpPr>
-          <p:cNvPr id="22" name="Rounded Rectangle 21"/>
+          <p:cNvPr id="23" name="Rounded Rectangle 22"/>
           <p:cNvSpPr/>
           <p:nvPr/>
         </p:nvSpPr>
@@ -3940,11 +3984,11 @@
             </a:avLst>
           </a:prstGeom>
           <a:solidFill>
-            <a:srgbClr val="F7F9FC"/>
+            <a:srgbClr val="F7F7F8"/>
           </a:solidFill>
           <a:ln>
             <a:solidFill>
-              <a:srgbClr val="E2E8F0"/>
+              <a:srgbClr val="E3E6EB"/>
             </a:solidFill>
           </a:ln>
           <a:effectLst/>
@@ -3973,7 +4017,7 @@
       </p:sp>
       <p:sp>
         <p:nvSpPr>
-          <p:cNvPr id="23" name="Rectangle 22"/>
+          <p:cNvPr id="24" name="Rectangle 23"/>
           <p:cNvSpPr/>
           <p:nvPr/>
         </p:nvSpPr>
@@ -3986,7 +4030,7 @@
             <a:avLst/>
           </a:prstGeom>
           <a:solidFill>
-            <a:srgbClr val="6D28D9"/>
+            <a:srgbClr val="F26522"/>
           </a:solidFill>
           <a:ln>
             <a:noFill/>
@@ -4017,7 +4061,7 @@
       </p:sp>
       <p:sp>
         <p:nvSpPr>
-          <p:cNvPr id="24" name="TextBox 23"/>
+          <p:cNvPr id="25" name="TextBox 24"/>
           <p:cNvSpPr txBox="1"/>
           <p:nvPr/>
         </p:nvSpPr>
@@ -4045,7 +4089,7 @@
             <a:r>
               <a:rPr sz="1400" b="1">
                 <a:solidFill>
-                  <a:srgbClr val="0B1F3A"/>
+                  <a:srgbClr val="111418"/>
                 </a:solidFill>
                 <a:latin typeface="Calibri"/>
               </a:rPr>
@@ -4056,7 +4100,7 @@
       </p:sp>
       <p:sp>
         <p:nvSpPr>
-          <p:cNvPr id="25" name="TextBox 24"/>
+          <p:cNvPr id="26" name="TextBox 25"/>
           <p:cNvSpPr txBox="1"/>
           <p:nvPr/>
         </p:nvSpPr>
@@ -4126,7 +4170,7 @@
             <a:avLst/>
           </a:prstGeom>
           <a:solidFill>
-            <a:srgbClr val="6D28D9"/>
+            <a:srgbClr val="F26522"/>
           </a:solidFill>
           <a:ln>
             <a:noFill/>
@@ -4185,7 +4229,7 @@
             <a:r>
               <a:rPr sz="1000" b="1">
                 <a:solidFill>
-                  <a:srgbClr val="6D28D9"/>
+                  <a:srgbClr val="F26522"/>
                 </a:solidFill>
                 <a:latin typeface="Calibri"/>
               </a:rPr>
@@ -4224,7 +4268,7 @@
             <a:r>
               <a:rPr sz="2600" b="1">
                 <a:solidFill>
-                  <a:srgbClr val="0B1F3A"/>
+                  <a:srgbClr val="111418"/>
                 </a:solidFill>
                 <a:latin typeface="Calibri"/>
               </a:rPr>
@@ -4248,7 +4292,7 @@
             <a:avLst/>
           </a:prstGeom>
           <a:solidFill>
-            <a:srgbClr val="0B1F3A"/>
+            <a:srgbClr val="111418"/>
           </a:solidFill>
           <a:ln>
             <a:noFill/>
@@ -4385,7 +4429,7 @@
             <a:r>
               <a:rPr sz="1000" b="1">
                 <a:solidFill>
-                  <a:srgbClr val="6D28D9"/>
+                  <a:srgbClr val="F26522"/>
                 </a:solidFill>
                 <a:latin typeface="Calibri"/>
               </a:rPr>
@@ -4411,11 +4455,11 @@
             </a:avLst>
           </a:prstGeom>
           <a:solidFill>
-            <a:srgbClr val="F7F9FC"/>
+            <a:srgbClr val="F7F7F8"/>
           </a:solidFill>
           <a:ln>
             <a:solidFill>
-              <a:srgbClr val="E2E8F0"/>
+              <a:srgbClr val="E3E6EB"/>
             </a:solidFill>
           </a:ln>
           <a:effectLst/>
@@ -4472,7 +4516,7 @@
             <a:r>
               <a:rPr sz="1200" b="1">
                 <a:solidFill>
-                  <a:srgbClr val="0B1F3A"/>
+                  <a:srgbClr val="111418"/>
                 </a:solidFill>
                 <a:latin typeface="Calibri"/>
               </a:rPr>
@@ -4542,11 +4586,11 @@
             </a:avLst>
           </a:prstGeom>
           <a:solidFill>
-            <a:srgbClr val="F7F9FC"/>
+            <a:srgbClr val="F7F7F8"/>
           </a:solidFill>
           <a:ln>
             <a:solidFill>
-              <a:srgbClr val="E2E8F0"/>
+              <a:srgbClr val="E3E6EB"/>
             </a:solidFill>
           </a:ln>
           <a:effectLst/>
@@ -4603,7 +4647,7 @@
             <a:r>
               <a:rPr sz="1200" b="1">
                 <a:solidFill>
-                  <a:srgbClr val="0B1F3A"/>
+                  <a:srgbClr val="111418"/>
                 </a:solidFill>
                 <a:latin typeface="Calibri"/>
               </a:rPr>
@@ -4673,11 +4717,11 @@
             </a:avLst>
           </a:prstGeom>
           <a:solidFill>
-            <a:srgbClr val="F7F9FC"/>
+            <a:srgbClr val="F7F7F8"/>
           </a:solidFill>
           <a:ln>
             <a:solidFill>
-              <a:srgbClr val="E2E8F0"/>
+              <a:srgbClr val="E3E6EB"/>
             </a:solidFill>
           </a:ln>
           <a:effectLst/>
@@ -4734,7 +4778,7 @@
             <a:r>
               <a:rPr sz="1200" b="1">
                 <a:solidFill>
-                  <a:srgbClr val="0B1F3A"/>
+                  <a:srgbClr val="111418"/>
                 </a:solidFill>
                 <a:latin typeface="Calibri"/>
               </a:rPr>
@@ -4804,11 +4848,11 @@
             </a:avLst>
           </a:prstGeom>
           <a:solidFill>
-            <a:srgbClr val="F7F9FC"/>
+            <a:srgbClr val="F7F7F8"/>
           </a:solidFill>
           <a:ln>
             <a:solidFill>
-              <a:srgbClr val="E2E8F0"/>
+              <a:srgbClr val="E3E6EB"/>
             </a:solidFill>
           </a:ln>
           <a:effectLst/>
@@ -4865,7 +4909,7 @@
             <a:r>
               <a:rPr sz="1200" b="1">
                 <a:solidFill>
-                  <a:srgbClr val="0B1F3A"/>
+                  <a:srgbClr val="111418"/>
                 </a:solidFill>
                 <a:latin typeface="Calibri"/>
               </a:rPr>
@@ -4935,11 +4979,11 @@
             </a:avLst>
           </a:prstGeom>
           <a:solidFill>
-            <a:srgbClr val="F7F9FC"/>
+            <a:srgbClr val="F7F7F8"/>
           </a:solidFill>
           <a:ln>
             <a:solidFill>
-              <a:srgbClr val="E2E8F0"/>
+              <a:srgbClr val="E3E6EB"/>
             </a:solidFill>
           </a:ln>
           <a:effectLst/>
@@ -4996,7 +5040,7 @@
             <a:r>
               <a:rPr sz="1200" b="1">
                 <a:solidFill>
-                  <a:srgbClr val="0B1F3A"/>
+                  <a:srgbClr val="111418"/>
                 </a:solidFill>
                 <a:latin typeface="Calibri"/>
               </a:rPr>
@@ -5066,11 +5110,11 @@
             </a:avLst>
           </a:prstGeom>
           <a:solidFill>
-            <a:srgbClr val="F7F9FC"/>
+            <a:srgbClr val="F7F7F8"/>
           </a:solidFill>
           <a:ln>
             <a:solidFill>
-              <a:srgbClr val="E2E8F0"/>
+              <a:srgbClr val="E3E6EB"/>
             </a:solidFill>
           </a:ln>
           <a:effectLst/>
@@ -5127,7 +5171,7 @@
             <a:r>
               <a:rPr sz="1200" b="1">
                 <a:solidFill>
-                  <a:srgbClr val="0B1F3A"/>
+                  <a:srgbClr val="111418"/>
                 </a:solidFill>
                 <a:latin typeface="Calibri"/>
               </a:rPr>
@@ -5201,7 +5245,7 @@
           </a:solidFill>
           <a:ln>
             <a:solidFill>
-              <a:srgbClr val="E2E8F0"/>
+              <a:srgbClr val="E3E6EB"/>
             </a:solidFill>
           </a:ln>
           <a:effectLst/>
@@ -5284,11 +5328,11 @@
             </a:avLst>
           </a:prstGeom>
           <a:solidFill>
-            <a:srgbClr val="F7F9FC"/>
+            <a:srgbClr val="F7F7F8"/>
           </a:solidFill>
           <a:ln w="9525">
             <a:solidFill>
-              <a:srgbClr val="E2E8F0"/>
+              <a:srgbClr val="E3E6EB"/>
             </a:solidFill>
           </a:ln>
           <a:effectLst/>
@@ -5332,7 +5376,7 @@
             </a:avLst>
           </a:prstGeom>
           <a:solidFill>
-            <a:srgbClr val="EDE9FE"/>
+            <a:srgbClr val="FFECDF"/>
           </a:solidFill>
           <a:ln>
             <a:noFill/>
@@ -5391,7 +5435,7 @@
             <a:r>
               <a:rPr sz="900" b="1">
                 <a:solidFill>
-                  <a:srgbClr val="6D28D9"/>
+                  <a:srgbClr val="F26522"/>
                 </a:solidFill>
                 <a:latin typeface="Calibri"/>
               </a:rPr>
@@ -5430,7 +5474,7 @@
             <a:r>
               <a:rPr sz="1500" b="1">
                 <a:solidFill>
-                  <a:srgbClr val="0B1F3A"/>
+                  <a:srgbClr val="111418"/>
                 </a:solidFill>
                 <a:latin typeface="Calibri"/>
               </a:rPr>
@@ -5472,7 +5516,7 @@
             <a:r>
               <a:rPr sz="1100" b="1">
                 <a:solidFill>
-                  <a:srgbClr val="6D28D9"/>
+                  <a:srgbClr val="F26522"/>
                 </a:solidFill>
                 <a:latin typeface="Calibri"/>
               </a:rPr>
@@ -5481,7 +5525,7 @@
             <a:r>
               <a:rPr sz="1100">
                 <a:solidFill>
-                  <a:srgbClr val="1F2937"/>
+                  <a:srgbClr val="1F242C"/>
                 </a:solidFill>
                 <a:latin typeface="Calibri"/>
               </a:rPr>
@@ -5500,7 +5544,7 @@
             <a:r>
               <a:rPr sz="1100" b="1">
                 <a:solidFill>
-                  <a:srgbClr val="6D28D9"/>
+                  <a:srgbClr val="F26522"/>
                 </a:solidFill>
                 <a:latin typeface="Calibri"/>
               </a:rPr>
@@ -5509,7 +5553,7 @@
             <a:r>
               <a:rPr sz="1100">
                 <a:solidFill>
-                  <a:srgbClr val="1F2937"/>
+                  <a:srgbClr val="1F242C"/>
                 </a:solidFill>
                 <a:latin typeface="Calibri"/>
               </a:rPr>
@@ -5528,7 +5572,7 @@
             <a:r>
               <a:rPr sz="1100" b="1">
                 <a:solidFill>
-                  <a:srgbClr val="6D28D9"/>
+                  <a:srgbClr val="F26522"/>
                 </a:solidFill>
                 <a:latin typeface="Calibri"/>
               </a:rPr>
@@ -5537,7 +5581,7 @@
             <a:r>
               <a:rPr sz="1100">
                 <a:solidFill>
-                  <a:srgbClr val="1F2937"/>
+                  <a:srgbClr val="1F242C"/>
                 </a:solidFill>
                 <a:latin typeface="Calibri"/>
               </a:rPr>
@@ -5556,7 +5600,7 @@
             <a:r>
               <a:rPr sz="1100" b="1">
                 <a:solidFill>
-                  <a:srgbClr val="6D28D9"/>
+                  <a:srgbClr val="F26522"/>
                 </a:solidFill>
                 <a:latin typeface="Calibri"/>
               </a:rPr>
@@ -5565,7 +5609,7 @@
             <a:r>
               <a:rPr sz="1100">
                 <a:solidFill>
-                  <a:srgbClr val="1F2937"/>
+                  <a:srgbClr val="1F242C"/>
                 </a:solidFill>
                 <a:latin typeface="Calibri"/>
               </a:rPr>
@@ -5591,11 +5635,11 @@
             </a:avLst>
           </a:prstGeom>
           <a:solidFill>
-            <a:srgbClr val="F7F9FC"/>
+            <a:srgbClr val="F7F7F8"/>
           </a:solidFill>
           <a:ln w="9525">
             <a:solidFill>
-              <a:srgbClr val="E2E8F0"/>
+              <a:srgbClr val="E3E6EB"/>
             </a:solidFill>
           </a:ln>
           <a:effectLst/>
@@ -5639,7 +5683,7 @@
             </a:avLst>
           </a:prstGeom>
           <a:solidFill>
-            <a:srgbClr val="EDE9FE"/>
+            <a:srgbClr val="FFECDF"/>
           </a:solidFill>
           <a:ln>
             <a:noFill/>
@@ -5698,7 +5742,7 @@
             <a:r>
               <a:rPr sz="900" b="1">
                 <a:solidFill>
-                  <a:srgbClr val="6D28D9"/>
+                  <a:srgbClr val="F26522"/>
                 </a:solidFill>
                 <a:latin typeface="Calibri"/>
               </a:rPr>
@@ -5737,7 +5781,7 @@
             <a:r>
               <a:rPr sz="1500" b="1">
                 <a:solidFill>
-                  <a:srgbClr val="0B1F3A"/>
+                  <a:srgbClr val="111418"/>
                 </a:solidFill>
                 <a:latin typeface="Calibri"/>
               </a:rPr>
@@ -5779,7 +5823,7 @@
             <a:r>
               <a:rPr sz="1100" b="1">
                 <a:solidFill>
-                  <a:srgbClr val="6D28D9"/>
+                  <a:srgbClr val="F26522"/>
                 </a:solidFill>
                 <a:latin typeface="Calibri"/>
               </a:rPr>
@@ -5788,7 +5832,7 @@
             <a:r>
               <a:rPr sz="1100">
                 <a:solidFill>
-                  <a:srgbClr val="1F2937"/>
+                  <a:srgbClr val="1F242C"/>
                 </a:solidFill>
                 <a:latin typeface="Calibri"/>
               </a:rPr>
@@ -5807,7 +5851,7 @@
             <a:r>
               <a:rPr sz="1100" b="1">
                 <a:solidFill>
-                  <a:srgbClr val="6D28D9"/>
+                  <a:srgbClr val="F26522"/>
                 </a:solidFill>
                 <a:latin typeface="Calibri"/>
               </a:rPr>
@@ -5816,7 +5860,7 @@
             <a:r>
               <a:rPr sz="1100">
                 <a:solidFill>
-                  <a:srgbClr val="1F2937"/>
+                  <a:srgbClr val="1F242C"/>
                 </a:solidFill>
                 <a:latin typeface="Calibri"/>
               </a:rPr>
@@ -5835,7 +5879,7 @@
             <a:r>
               <a:rPr sz="1100" b="1">
                 <a:solidFill>
-                  <a:srgbClr val="6D28D9"/>
+                  <a:srgbClr val="F26522"/>
                 </a:solidFill>
                 <a:latin typeface="Calibri"/>
               </a:rPr>
@@ -5844,7 +5888,7 @@
             <a:r>
               <a:rPr sz="1100">
                 <a:solidFill>
-                  <a:srgbClr val="1F2937"/>
+                  <a:srgbClr val="1F242C"/>
                 </a:solidFill>
                 <a:latin typeface="Calibri"/>
               </a:rPr>
@@ -5863,7 +5907,7 @@
             <a:r>
               <a:rPr sz="1100" b="1">
                 <a:solidFill>
-                  <a:srgbClr val="6D28D9"/>
+                  <a:srgbClr val="F26522"/>
                 </a:solidFill>
                 <a:latin typeface="Calibri"/>
               </a:rPr>
@@ -5872,7 +5916,7 @@
             <a:r>
               <a:rPr sz="1100">
                 <a:solidFill>
-                  <a:srgbClr val="1F2937"/>
+                  <a:srgbClr val="1F242C"/>
                 </a:solidFill>
                 <a:latin typeface="Calibri"/>
               </a:rPr>
@@ -5914,7 +5958,7 @@
             <a:avLst/>
           </a:prstGeom>
           <a:solidFill>
-            <a:srgbClr val="6D28D9"/>
+            <a:srgbClr val="F26522"/>
           </a:solidFill>
           <a:ln>
             <a:noFill/>
@@ -5973,7 +6017,7 @@
             <a:r>
               <a:rPr sz="1000" b="1">
                 <a:solidFill>
-                  <a:srgbClr val="6D28D9"/>
+                  <a:srgbClr val="F26522"/>
                 </a:solidFill>
                 <a:latin typeface="Calibri"/>
               </a:rPr>
@@ -6012,7 +6056,7 @@
             <a:r>
               <a:rPr sz="2600" b="1">
                 <a:solidFill>
-                  <a:srgbClr val="0B1F3A"/>
+                  <a:srgbClr val="111418"/>
                 </a:solidFill>
                 <a:latin typeface="Calibri"/>
               </a:rPr>
@@ -6036,7 +6080,7 @@
             <a:avLst/>
           </a:prstGeom>
           <a:solidFill>
-            <a:srgbClr val="0B1F3A"/>
+            <a:srgbClr val="111418"/>
           </a:solidFill>
           <a:ln>
             <a:noFill/>
@@ -6199,11 +6243,11 @@
             </a:avLst>
           </a:prstGeom>
           <a:solidFill>
-            <a:srgbClr val="F7F9FC"/>
+            <a:srgbClr val="F7F7F8"/>
           </a:solidFill>
           <a:ln>
             <a:solidFill>
-              <a:srgbClr val="E2E8F0"/>
+              <a:srgbClr val="E3E6EB"/>
             </a:solidFill>
           </a:ln>
           <a:effectLst/>
@@ -6245,7 +6289,7 @@
             <a:avLst/>
           </a:prstGeom>
           <a:solidFill>
-            <a:srgbClr val="6D28D9"/>
+            <a:srgbClr val="F26522"/>
           </a:solidFill>
           <a:ln>
             <a:noFill/>
@@ -6304,7 +6348,7 @@
             <a:r>
               <a:rPr sz="1500" b="1">
                 <a:solidFill>
-                  <a:srgbClr val="0B1F3A"/>
+                  <a:srgbClr val="111418"/>
                 </a:solidFill>
                 <a:latin typeface="Calibri"/>
               </a:rPr>
@@ -6343,7 +6387,7 @@
             <a:r>
               <a:rPr sz="1100" b="1">
                 <a:solidFill>
-                  <a:srgbClr val="6D28D9"/>
+                  <a:srgbClr val="F26522"/>
                 </a:solidFill>
                 <a:latin typeface="Calibri"/>
               </a:rPr>
@@ -6385,7 +6429,7 @@
             <a:r>
               <a:rPr sz="1100" b="1">
                 <a:solidFill>
-                  <a:srgbClr val="6D28D9"/>
+                  <a:srgbClr val="F26522"/>
                 </a:solidFill>
                 <a:latin typeface="Calibri"/>
               </a:rPr>
@@ -6394,7 +6438,7 @@
             <a:r>
               <a:rPr sz="1100">
                 <a:solidFill>
-                  <a:srgbClr val="1F2937"/>
+                  <a:srgbClr val="1F242C"/>
                 </a:solidFill>
                 <a:latin typeface="Calibri"/>
               </a:rPr>
@@ -6413,7 +6457,7 @@
             <a:r>
               <a:rPr sz="1100" b="1">
                 <a:solidFill>
-                  <a:srgbClr val="6D28D9"/>
+                  <a:srgbClr val="F26522"/>
                 </a:solidFill>
                 <a:latin typeface="Calibri"/>
               </a:rPr>
@@ -6422,7 +6466,7 @@
             <a:r>
               <a:rPr sz="1100">
                 <a:solidFill>
-                  <a:srgbClr val="1F2937"/>
+                  <a:srgbClr val="1F242C"/>
                 </a:solidFill>
                 <a:latin typeface="Calibri"/>
               </a:rPr>
@@ -6441,7 +6485,7 @@
             <a:r>
               <a:rPr sz="1100" b="1">
                 <a:solidFill>
-                  <a:srgbClr val="6D28D9"/>
+                  <a:srgbClr val="F26522"/>
                 </a:solidFill>
                 <a:latin typeface="Calibri"/>
               </a:rPr>
@@ -6450,7 +6494,7 @@
             <a:r>
               <a:rPr sz="1100">
                 <a:solidFill>
-                  <a:srgbClr val="1F2937"/>
+                  <a:srgbClr val="1F242C"/>
                 </a:solidFill>
                 <a:latin typeface="Calibri"/>
               </a:rPr>
@@ -6476,11 +6520,11 @@
             </a:avLst>
           </a:prstGeom>
           <a:solidFill>
-            <a:srgbClr val="F7F9FC"/>
+            <a:srgbClr val="F7F7F8"/>
           </a:solidFill>
           <a:ln>
             <a:solidFill>
-              <a:srgbClr val="E2E8F0"/>
+              <a:srgbClr val="E3E6EB"/>
             </a:solidFill>
           </a:ln>
           <a:effectLst/>
@@ -6522,7 +6566,7 @@
             <a:avLst/>
           </a:prstGeom>
           <a:solidFill>
-            <a:srgbClr val="6D28D9"/>
+            <a:srgbClr val="F26522"/>
           </a:solidFill>
           <a:ln>
             <a:noFill/>
@@ -6581,7 +6625,7 @@
             <a:r>
               <a:rPr sz="1500" b="1">
                 <a:solidFill>
-                  <a:srgbClr val="0B1F3A"/>
+                  <a:srgbClr val="111418"/>
                 </a:solidFill>
                 <a:latin typeface="Calibri"/>
               </a:rPr>
@@ -6620,7 +6664,7 @@
             <a:r>
               <a:rPr sz="1100" b="1">
                 <a:solidFill>
-                  <a:srgbClr val="6D28D9"/>
+                  <a:srgbClr val="F26522"/>
                 </a:solidFill>
                 <a:latin typeface="Calibri"/>
               </a:rPr>
@@ -6662,7 +6706,7 @@
             <a:r>
               <a:rPr sz="1100" b="1">
                 <a:solidFill>
-                  <a:srgbClr val="6D28D9"/>
+                  <a:srgbClr val="F26522"/>
                 </a:solidFill>
                 <a:latin typeface="Calibri"/>
               </a:rPr>
@@ -6671,7 +6715,7 @@
             <a:r>
               <a:rPr sz="1100">
                 <a:solidFill>
-                  <a:srgbClr val="1F2937"/>
+                  <a:srgbClr val="1F242C"/>
                 </a:solidFill>
                 <a:latin typeface="Calibri"/>
               </a:rPr>
@@ -6690,7 +6734,7 @@
             <a:r>
               <a:rPr sz="1100" b="1">
                 <a:solidFill>
-                  <a:srgbClr val="6D28D9"/>
+                  <a:srgbClr val="F26522"/>
                 </a:solidFill>
                 <a:latin typeface="Calibri"/>
               </a:rPr>
@@ -6699,7 +6743,7 @@
             <a:r>
               <a:rPr sz="1100">
                 <a:solidFill>
-                  <a:srgbClr val="1F2937"/>
+                  <a:srgbClr val="1F242C"/>
                 </a:solidFill>
                 <a:latin typeface="Calibri"/>
               </a:rPr>
@@ -6718,7 +6762,7 @@
             <a:r>
               <a:rPr sz="1100" b="1">
                 <a:solidFill>
-                  <a:srgbClr val="6D28D9"/>
+                  <a:srgbClr val="F26522"/>
                 </a:solidFill>
                 <a:latin typeface="Calibri"/>
               </a:rPr>
@@ -6727,7 +6771,7 @@
             <a:r>
               <a:rPr sz="1100">
                 <a:solidFill>
-                  <a:srgbClr val="1F2937"/>
+                  <a:srgbClr val="1F242C"/>
                 </a:solidFill>
                 <a:latin typeface="Calibri"/>
               </a:rPr>
@@ -6753,11 +6797,11 @@
             </a:avLst>
           </a:prstGeom>
           <a:solidFill>
-            <a:srgbClr val="F7F9FC"/>
+            <a:srgbClr val="F7F7F8"/>
           </a:solidFill>
           <a:ln>
             <a:solidFill>
-              <a:srgbClr val="E2E8F0"/>
+              <a:srgbClr val="E3E6EB"/>
             </a:solidFill>
           </a:ln>
           <a:effectLst/>
@@ -6799,7 +6843,7 @@
             <a:avLst/>
           </a:prstGeom>
           <a:solidFill>
-            <a:srgbClr val="6D28D9"/>
+            <a:srgbClr val="F26522"/>
           </a:solidFill>
           <a:ln>
             <a:noFill/>
@@ -6858,7 +6902,7 @@
             <a:r>
               <a:rPr sz="1500" b="1">
                 <a:solidFill>
-                  <a:srgbClr val="0B1F3A"/>
+                  <a:srgbClr val="111418"/>
                 </a:solidFill>
                 <a:latin typeface="Calibri"/>
               </a:rPr>
@@ -6897,7 +6941,7 @@
             <a:r>
               <a:rPr sz="1100" b="1">
                 <a:solidFill>
-                  <a:srgbClr val="6D28D9"/>
+                  <a:srgbClr val="F26522"/>
                 </a:solidFill>
                 <a:latin typeface="Calibri"/>
               </a:rPr>
@@ -6939,7 +6983,7 @@
             <a:r>
               <a:rPr sz="1100" b="1">
                 <a:solidFill>
-                  <a:srgbClr val="6D28D9"/>
+                  <a:srgbClr val="F26522"/>
                 </a:solidFill>
                 <a:latin typeface="Calibri"/>
               </a:rPr>
@@ -6948,7 +6992,7 @@
             <a:r>
               <a:rPr sz="1100">
                 <a:solidFill>
-                  <a:srgbClr val="1F2937"/>
+                  <a:srgbClr val="1F242C"/>
                 </a:solidFill>
                 <a:latin typeface="Calibri"/>
               </a:rPr>
@@ -6967,7 +7011,7 @@
             <a:r>
               <a:rPr sz="1100" b="1">
                 <a:solidFill>
-                  <a:srgbClr val="6D28D9"/>
+                  <a:srgbClr val="F26522"/>
                 </a:solidFill>
                 <a:latin typeface="Calibri"/>
               </a:rPr>
@@ -6976,7 +7020,7 @@
             <a:r>
               <a:rPr sz="1100">
                 <a:solidFill>
-                  <a:srgbClr val="1F2937"/>
+                  <a:srgbClr val="1F242C"/>
                 </a:solidFill>
                 <a:latin typeface="Calibri"/>
               </a:rPr>
@@ -6995,7 +7039,7 @@
             <a:r>
               <a:rPr sz="1100" b="1">
                 <a:solidFill>
-                  <a:srgbClr val="6D28D9"/>
+                  <a:srgbClr val="F26522"/>
                 </a:solidFill>
                 <a:latin typeface="Calibri"/>
               </a:rPr>
@@ -7004,7 +7048,7 @@
             <a:r>
               <a:rPr sz="1100">
                 <a:solidFill>
-                  <a:srgbClr val="1F2937"/>
+                  <a:srgbClr val="1F242C"/>
                 </a:solidFill>
                 <a:latin typeface="Calibri"/>
               </a:rPr>
@@ -7030,11 +7074,11 @@
             </a:avLst>
           </a:prstGeom>
           <a:solidFill>
-            <a:srgbClr val="F7F9FC"/>
+            <a:srgbClr val="F7F7F8"/>
           </a:solidFill>
           <a:ln>
             <a:solidFill>
-              <a:srgbClr val="E2E8F0"/>
+              <a:srgbClr val="E3E6EB"/>
             </a:solidFill>
           </a:ln>
           <a:effectLst/>
@@ -7076,7 +7120,7 @@
             <a:avLst/>
           </a:prstGeom>
           <a:solidFill>
-            <a:srgbClr val="6D28D9"/>
+            <a:srgbClr val="F26522"/>
           </a:solidFill>
           <a:ln>
             <a:noFill/>
@@ -7135,7 +7179,7 @@
             <a:r>
               <a:rPr sz="1500" b="1">
                 <a:solidFill>
-                  <a:srgbClr val="0B1F3A"/>
+                  <a:srgbClr val="111418"/>
                 </a:solidFill>
                 <a:latin typeface="Calibri"/>
               </a:rPr>
@@ -7174,7 +7218,7 @@
             <a:r>
               <a:rPr sz="1100" b="1">
                 <a:solidFill>
-                  <a:srgbClr val="6D28D9"/>
+                  <a:srgbClr val="F26522"/>
                 </a:solidFill>
                 <a:latin typeface="Calibri"/>
               </a:rPr>
@@ -7216,7 +7260,7 @@
             <a:r>
               <a:rPr sz="1100" b="1">
                 <a:solidFill>
-                  <a:srgbClr val="6D28D9"/>
+                  <a:srgbClr val="F26522"/>
                 </a:solidFill>
                 <a:latin typeface="Calibri"/>
               </a:rPr>
@@ -7225,7 +7269,7 @@
             <a:r>
               <a:rPr sz="1100">
                 <a:solidFill>
-                  <a:srgbClr val="1F2937"/>
+                  <a:srgbClr val="1F242C"/>
                 </a:solidFill>
                 <a:latin typeface="Calibri"/>
               </a:rPr>
@@ -7244,7 +7288,7 @@
             <a:r>
               <a:rPr sz="1100" b="1">
                 <a:solidFill>
-                  <a:srgbClr val="6D28D9"/>
+                  <a:srgbClr val="F26522"/>
                 </a:solidFill>
                 <a:latin typeface="Calibri"/>
               </a:rPr>
@@ -7253,7 +7297,7 @@
             <a:r>
               <a:rPr sz="1100">
                 <a:solidFill>
-                  <a:srgbClr val="1F2937"/>
+                  <a:srgbClr val="1F242C"/>
                 </a:solidFill>
                 <a:latin typeface="Calibri"/>
               </a:rPr>
@@ -7272,7 +7316,7 @@
             <a:r>
               <a:rPr sz="1100" b="1">
                 <a:solidFill>
-                  <a:srgbClr val="6D28D9"/>
+                  <a:srgbClr val="F26522"/>
                 </a:solidFill>
                 <a:latin typeface="Calibri"/>
               </a:rPr>
@@ -7281,7 +7325,7 @@
             <a:r>
               <a:rPr sz="1100">
                 <a:solidFill>
-                  <a:srgbClr val="1F2937"/>
+                  <a:srgbClr val="1F242C"/>
                 </a:solidFill>
                 <a:latin typeface="Calibri"/>
               </a:rPr>
@@ -7323,7 +7367,7 @@
             <a:avLst/>
           </a:prstGeom>
           <a:solidFill>
-            <a:srgbClr val="6D28D9"/>
+            <a:srgbClr val="F26522"/>
           </a:solidFill>
           <a:ln>
             <a:noFill/>
@@ -7382,7 +7426,7 @@
             <a:r>
               <a:rPr sz="1000" b="1">
                 <a:solidFill>
-                  <a:srgbClr val="6D28D9"/>
+                  <a:srgbClr val="F26522"/>
                 </a:solidFill>
                 <a:latin typeface="Calibri"/>
               </a:rPr>
@@ -7421,7 +7465,7 @@
             <a:r>
               <a:rPr sz="2600" b="1">
                 <a:solidFill>
-                  <a:srgbClr val="0B1F3A"/>
+                  <a:srgbClr val="111418"/>
                 </a:solidFill>
                 <a:latin typeface="Calibri"/>
               </a:rPr>
@@ -7445,7 +7489,7 @@
             <a:avLst/>
           </a:prstGeom>
           <a:solidFill>
-            <a:srgbClr val="0B1F3A"/>
+            <a:srgbClr val="111418"/>
           </a:solidFill>
           <a:ln>
             <a:noFill/>
@@ -7569,11 +7613,11 @@
             </a:avLst>
           </a:prstGeom>
           <a:solidFill>
-            <a:srgbClr val="F7F9FC"/>
+            <a:srgbClr val="F7F7F8"/>
           </a:solidFill>
           <a:ln>
             <a:solidFill>
-              <a:srgbClr val="E2E8F0"/>
+              <a:srgbClr val="E3E6EB"/>
             </a:solidFill>
           </a:ln>
           <a:effectLst/>
@@ -7630,7 +7674,7 @@
             <a:r>
               <a:rPr sz="1700" b="1">
                 <a:solidFill>
-                  <a:srgbClr val="0B1F3A"/>
+                  <a:srgbClr val="111418"/>
                 </a:solidFill>
                 <a:latin typeface="Calibri"/>
               </a:rPr>
@@ -7669,7 +7713,7 @@
             <a:r>
               <a:rPr sz="1100" b="1">
                 <a:solidFill>
-                  <a:srgbClr val="6D28D9"/>
+                  <a:srgbClr val="F26522"/>
                 </a:solidFill>
                 <a:latin typeface="Calibri"/>
               </a:rPr>
@@ -7693,7 +7737,7 @@
             <a:avLst/>
           </a:prstGeom>
           <a:solidFill>
-            <a:srgbClr val="6D28D9"/>
+            <a:srgbClr val="F26522"/>
           </a:solidFill>
           <a:ln>
             <a:noFill/>
@@ -7755,7 +7799,7 @@
             <a:r>
               <a:rPr sz="1100" b="1">
                 <a:solidFill>
-                  <a:srgbClr val="6D28D9"/>
+                  <a:srgbClr val="F26522"/>
                 </a:solidFill>
                 <a:latin typeface="Calibri"/>
               </a:rPr>
@@ -7764,7 +7808,7 @@
             <a:r>
               <a:rPr sz="1100">
                 <a:solidFill>
-                  <a:srgbClr val="1F2937"/>
+                  <a:srgbClr val="1F242C"/>
                 </a:solidFill>
                 <a:latin typeface="Calibri"/>
               </a:rPr>
@@ -7783,7 +7827,7 @@
             <a:r>
               <a:rPr sz="1100" b="1">
                 <a:solidFill>
-                  <a:srgbClr val="6D28D9"/>
+                  <a:srgbClr val="F26522"/>
                 </a:solidFill>
                 <a:latin typeface="Calibri"/>
               </a:rPr>
@@ -7792,7 +7836,7 @@
             <a:r>
               <a:rPr sz="1100">
                 <a:solidFill>
-                  <a:srgbClr val="1F2937"/>
+                  <a:srgbClr val="1F242C"/>
                 </a:solidFill>
                 <a:latin typeface="Calibri"/>
               </a:rPr>
@@ -7811,7 +7855,7 @@
             <a:r>
               <a:rPr sz="1100" b="1">
                 <a:solidFill>
-                  <a:srgbClr val="6D28D9"/>
+                  <a:srgbClr val="F26522"/>
                 </a:solidFill>
                 <a:latin typeface="Calibri"/>
               </a:rPr>
@@ -7820,7 +7864,7 @@
             <a:r>
               <a:rPr sz="1100">
                 <a:solidFill>
-                  <a:srgbClr val="1F2937"/>
+                  <a:srgbClr val="1F242C"/>
                 </a:solidFill>
                 <a:latin typeface="Calibri"/>
               </a:rPr>
@@ -7846,11 +7890,11 @@
             </a:avLst>
           </a:prstGeom>
           <a:solidFill>
-            <a:srgbClr val="F7F9FC"/>
+            <a:srgbClr val="F7F7F8"/>
           </a:solidFill>
           <a:ln>
             <a:solidFill>
-              <a:srgbClr val="E2E8F0"/>
+              <a:srgbClr val="E3E6EB"/>
             </a:solidFill>
           </a:ln>
           <a:effectLst/>
@@ -7907,7 +7951,7 @@
             <a:r>
               <a:rPr sz="1700" b="1">
                 <a:solidFill>
-                  <a:srgbClr val="0B1F3A"/>
+                  <a:srgbClr val="111418"/>
                 </a:solidFill>
                 <a:latin typeface="Calibri"/>
               </a:rPr>
@@ -7946,7 +7990,7 @@
             <a:r>
               <a:rPr sz="1100" b="1">
                 <a:solidFill>
-                  <a:srgbClr val="6D28D9"/>
+                  <a:srgbClr val="F26522"/>
                 </a:solidFill>
                 <a:latin typeface="Calibri"/>
               </a:rPr>
@@ -7970,7 +8014,7 @@
             <a:avLst/>
           </a:prstGeom>
           <a:solidFill>
-            <a:srgbClr val="6D28D9"/>
+            <a:srgbClr val="F26522"/>
           </a:solidFill>
           <a:ln>
             <a:noFill/>
@@ -8032,7 +8076,7 @@
             <a:r>
               <a:rPr sz="1100" b="1">
                 <a:solidFill>
-                  <a:srgbClr val="6D28D9"/>
+                  <a:srgbClr val="F26522"/>
                 </a:solidFill>
                 <a:latin typeface="Calibri"/>
               </a:rPr>
@@ -8041,7 +8085,7 @@
             <a:r>
               <a:rPr sz="1100">
                 <a:solidFill>
-                  <a:srgbClr val="1F2937"/>
+                  <a:srgbClr val="1F242C"/>
                 </a:solidFill>
                 <a:latin typeface="Calibri"/>
               </a:rPr>
@@ -8060,7 +8104,7 @@
             <a:r>
               <a:rPr sz="1100" b="1">
                 <a:solidFill>
-                  <a:srgbClr val="6D28D9"/>
+                  <a:srgbClr val="F26522"/>
                 </a:solidFill>
                 <a:latin typeface="Calibri"/>
               </a:rPr>
@@ -8069,7 +8113,7 @@
             <a:r>
               <a:rPr sz="1100">
                 <a:solidFill>
-                  <a:srgbClr val="1F2937"/>
+                  <a:srgbClr val="1F242C"/>
                 </a:solidFill>
                 <a:latin typeface="Calibri"/>
               </a:rPr>
@@ -8088,7 +8132,7 @@
             <a:r>
               <a:rPr sz="1100" b="1">
                 <a:solidFill>
-                  <a:srgbClr val="6D28D9"/>
+                  <a:srgbClr val="F26522"/>
                 </a:solidFill>
                 <a:latin typeface="Calibri"/>
               </a:rPr>
@@ -8097,7 +8141,7 @@
             <a:r>
               <a:rPr sz="1100">
                 <a:solidFill>
-                  <a:srgbClr val="1F2937"/>
+                  <a:srgbClr val="1F242C"/>
                 </a:solidFill>
                 <a:latin typeface="Calibri"/>
               </a:rPr>
@@ -8123,11 +8167,11 @@
             </a:avLst>
           </a:prstGeom>
           <a:solidFill>
-            <a:srgbClr val="F7F9FC"/>
+            <a:srgbClr val="F7F7F8"/>
           </a:solidFill>
           <a:ln>
             <a:solidFill>
-              <a:srgbClr val="E2E8F0"/>
+              <a:srgbClr val="E3E6EB"/>
             </a:solidFill>
           </a:ln>
           <a:effectLst/>
@@ -8184,7 +8228,7 @@
             <a:r>
               <a:rPr sz="1700" b="1">
                 <a:solidFill>
-                  <a:srgbClr val="0B1F3A"/>
+                  <a:srgbClr val="111418"/>
                 </a:solidFill>
                 <a:latin typeface="Calibri"/>
               </a:rPr>
@@ -8223,7 +8267,7 @@
             <a:r>
               <a:rPr sz="1100" b="1">
                 <a:solidFill>
-                  <a:srgbClr val="6D28D9"/>
+                  <a:srgbClr val="F26522"/>
                 </a:solidFill>
                 <a:latin typeface="Calibri"/>
               </a:rPr>
@@ -8247,7 +8291,7 @@
             <a:avLst/>
           </a:prstGeom>
           <a:solidFill>
-            <a:srgbClr val="6D28D9"/>
+            <a:srgbClr val="F26522"/>
           </a:solidFill>
           <a:ln>
             <a:noFill/>
@@ -8309,7 +8353,7 @@
             <a:r>
               <a:rPr sz="1100" b="1">
                 <a:solidFill>
-                  <a:srgbClr val="6D28D9"/>
+                  <a:srgbClr val="F26522"/>
                 </a:solidFill>
                 <a:latin typeface="Calibri"/>
               </a:rPr>
@@ -8318,7 +8362,7 @@
             <a:r>
               <a:rPr sz="1100">
                 <a:solidFill>
-                  <a:srgbClr val="1F2937"/>
+                  <a:srgbClr val="1F242C"/>
                 </a:solidFill>
                 <a:latin typeface="Calibri"/>
               </a:rPr>
@@ -8337,7 +8381,7 @@
             <a:r>
               <a:rPr sz="1100" b="1">
                 <a:solidFill>
-                  <a:srgbClr val="6D28D9"/>
+                  <a:srgbClr val="F26522"/>
                 </a:solidFill>
                 <a:latin typeface="Calibri"/>
               </a:rPr>
@@ -8346,7 +8390,7 @@
             <a:r>
               <a:rPr sz="1100">
                 <a:solidFill>
-                  <a:srgbClr val="1F2937"/>
+                  <a:srgbClr val="1F242C"/>
                 </a:solidFill>
                 <a:latin typeface="Calibri"/>
               </a:rPr>
@@ -8365,7 +8409,7 @@
             <a:r>
               <a:rPr sz="1100" b="1">
                 <a:solidFill>
-                  <a:srgbClr val="6D28D9"/>
+                  <a:srgbClr val="F26522"/>
                 </a:solidFill>
                 <a:latin typeface="Calibri"/>
               </a:rPr>
@@ -8374,7 +8418,7 @@
             <a:r>
               <a:rPr sz="1100">
                 <a:solidFill>
-                  <a:srgbClr val="1F2937"/>
+                  <a:srgbClr val="1F242C"/>
                 </a:solidFill>
                 <a:latin typeface="Calibri"/>
               </a:rPr>
@@ -8416,7 +8460,7 @@
             <a:avLst/>
           </a:prstGeom>
           <a:solidFill>
-            <a:srgbClr val="6D28D9"/>
+            <a:srgbClr val="F26522"/>
           </a:solidFill>
           <a:ln>
             <a:noFill/>
@@ -8475,7 +8519,7 @@
             <a:r>
               <a:rPr sz="1000" b="1">
                 <a:solidFill>
-                  <a:srgbClr val="6D28D9"/>
+                  <a:srgbClr val="F26522"/>
                 </a:solidFill>
                 <a:latin typeface="Calibri"/>
               </a:rPr>
@@ -8514,7 +8558,7 @@
             <a:r>
               <a:rPr sz="2600" b="1">
                 <a:solidFill>
-                  <a:srgbClr val="0B1F3A"/>
+                  <a:srgbClr val="111418"/>
                 </a:solidFill>
                 <a:latin typeface="Calibri"/>
               </a:rPr>
@@ -8538,7 +8582,7 @@
             <a:avLst/>
           </a:prstGeom>
           <a:solidFill>
-            <a:srgbClr val="0B1F3A"/>
+            <a:srgbClr val="111418"/>
           </a:solidFill>
           <a:ln>
             <a:noFill/>
@@ -8699,7 +8743,7 @@
             <a:avLst/>
           </a:prstGeom>
           <a:solidFill>
-            <a:srgbClr val="6D28D9"/>
+            <a:srgbClr val="F26522"/>
           </a:solidFill>
           <a:ln>
             <a:noFill/>
@@ -8797,7 +8841,7 @@
             <a:r>
               <a:rPr sz="1600" b="1">
                 <a:solidFill>
-                  <a:srgbClr val="0B1F3A"/>
+                  <a:srgbClr val="111418"/>
                 </a:solidFill>
                 <a:latin typeface="Calibri"/>
               </a:rPr>
@@ -8836,7 +8880,7 @@
             <a:r>
               <a:rPr sz="1200" b="0">
                 <a:solidFill>
-                  <a:srgbClr val="1F2937"/>
+                  <a:srgbClr val="1F242C"/>
                 </a:solidFill>
                 <a:latin typeface="Calibri"/>
               </a:rPr>
@@ -8860,7 +8904,7 @@
             <a:avLst/>
           </a:prstGeom>
           <a:solidFill>
-            <a:srgbClr val="6D28D9"/>
+            <a:srgbClr val="F26522"/>
           </a:solidFill>
           <a:ln>
             <a:noFill/>
@@ -8958,7 +9002,7 @@
             <a:r>
               <a:rPr sz="1600" b="1">
                 <a:solidFill>
-                  <a:srgbClr val="0B1F3A"/>
+                  <a:srgbClr val="111418"/>
                 </a:solidFill>
                 <a:latin typeface="Calibri"/>
               </a:rPr>
@@ -8997,7 +9041,7 @@
             <a:r>
               <a:rPr sz="1200" b="0">
                 <a:solidFill>
-                  <a:srgbClr val="1F2937"/>
+                  <a:srgbClr val="1F242C"/>
                 </a:solidFill>
                 <a:latin typeface="Calibri"/>
               </a:rPr>
@@ -9021,7 +9065,7 @@
             <a:avLst/>
           </a:prstGeom>
           <a:solidFill>
-            <a:srgbClr val="6D28D9"/>
+            <a:srgbClr val="F26522"/>
           </a:solidFill>
           <a:ln>
             <a:noFill/>
@@ -9119,7 +9163,7 @@
             <a:r>
               <a:rPr sz="1600" b="1">
                 <a:solidFill>
-                  <a:srgbClr val="0B1F3A"/>
+                  <a:srgbClr val="111418"/>
                 </a:solidFill>
                 <a:latin typeface="Calibri"/>
               </a:rPr>
@@ -9158,7 +9202,7 @@
             <a:r>
               <a:rPr sz="1200" b="0">
                 <a:solidFill>
-                  <a:srgbClr val="1F2937"/>
+                  <a:srgbClr val="1F242C"/>
                 </a:solidFill>
                 <a:latin typeface="Calibri"/>
               </a:rPr>
@@ -9200,7 +9244,7 @@
             <a:avLst/>
           </a:prstGeom>
           <a:solidFill>
-            <a:srgbClr val="6D28D9"/>
+            <a:srgbClr val="F26522"/>
           </a:solidFill>
           <a:ln>
             <a:noFill/>
@@ -9259,7 +9303,7 @@
             <a:r>
               <a:rPr sz="1000" b="1">
                 <a:solidFill>
-                  <a:srgbClr val="6D28D9"/>
+                  <a:srgbClr val="F26522"/>
                 </a:solidFill>
                 <a:latin typeface="Calibri"/>
               </a:rPr>
@@ -9298,7 +9342,7 @@
             <a:r>
               <a:rPr sz="2600" b="1">
                 <a:solidFill>
-                  <a:srgbClr val="0B1F3A"/>
+                  <a:srgbClr val="111418"/>
                 </a:solidFill>
                 <a:latin typeface="Calibri"/>
               </a:rPr>
@@ -9322,7 +9366,7 @@
             <a:avLst/>
           </a:prstGeom>
           <a:solidFill>
-            <a:srgbClr val="0B1F3A"/>
+            <a:srgbClr val="111418"/>
           </a:solidFill>
           <a:ln>
             <a:noFill/>
@@ -9446,11 +9490,11 @@
             </a:avLst>
           </a:prstGeom>
           <a:solidFill>
-            <a:srgbClr val="F7F9FC"/>
+            <a:srgbClr val="F7F7F8"/>
           </a:solidFill>
           <a:ln w="9525">
             <a:solidFill>
-              <a:srgbClr val="E2E8F0"/>
+              <a:srgbClr val="E3E6EB"/>
             </a:solidFill>
           </a:ln>
           <a:effectLst/>
@@ -9494,7 +9538,7 @@
             </a:avLst>
           </a:prstGeom>
           <a:solidFill>
-            <a:srgbClr val="EDE9FE"/>
+            <a:srgbClr val="FFECDF"/>
           </a:solidFill>
           <a:ln>
             <a:noFill/>
@@ -9553,7 +9597,7 @@
             <a:r>
               <a:rPr sz="900" b="1">
                 <a:solidFill>
-                  <a:srgbClr val="6D28D9"/>
+                  <a:srgbClr val="F26522"/>
                 </a:solidFill>
                 <a:latin typeface="Calibri"/>
               </a:rPr>
@@ -9592,7 +9636,7 @@
             <a:r>
               <a:rPr sz="1500" b="1">
                 <a:solidFill>
-                  <a:srgbClr val="0B1F3A"/>
+                  <a:srgbClr val="111418"/>
                 </a:solidFill>
                 <a:latin typeface="Calibri"/>
               </a:rPr>
@@ -9634,7 +9678,7 @@
             <a:r>
               <a:rPr sz="1100" b="1">
                 <a:solidFill>
-                  <a:srgbClr val="6D28D9"/>
+                  <a:srgbClr val="F26522"/>
                 </a:solidFill>
                 <a:latin typeface="Calibri"/>
               </a:rPr>
@@ -9643,7 +9687,7 @@
             <a:r>
               <a:rPr sz="1100">
                 <a:solidFill>
-                  <a:srgbClr val="1F2937"/>
+                  <a:srgbClr val="1F242C"/>
                 </a:solidFill>
                 <a:latin typeface="Calibri"/>
               </a:rPr>
@@ -9662,7 +9706,7 @@
             <a:r>
               <a:rPr sz="1100" b="1">
                 <a:solidFill>
-                  <a:srgbClr val="6D28D9"/>
+                  <a:srgbClr val="F26522"/>
                 </a:solidFill>
                 <a:latin typeface="Calibri"/>
               </a:rPr>
@@ -9671,7 +9715,7 @@
             <a:r>
               <a:rPr sz="1100">
                 <a:solidFill>
-                  <a:srgbClr val="1F2937"/>
+                  <a:srgbClr val="1F242C"/>
                 </a:solidFill>
                 <a:latin typeface="Calibri"/>
               </a:rPr>
@@ -9690,7 +9734,7 @@
             <a:r>
               <a:rPr sz="1100" b="1">
                 <a:solidFill>
-                  <a:srgbClr val="6D28D9"/>
+                  <a:srgbClr val="F26522"/>
                 </a:solidFill>
                 <a:latin typeface="Calibri"/>
               </a:rPr>
@@ -9699,7 +9743,7 @@
             <a:r>
               <a:rPr sz="1100">
                 <a:solidFill>
-                  <a:srgbClr val="1F2937"/>
+                  <a:srgbClr val="1F242C"/>
                 </a:solidFill>
                 <a:latin typeface="Calibri"/>
               </a:rPr>
@@ -9718,7 +9762,7 @@
             <a:r>
               <a:rPr sz="1100" b="1">
                 <a:solidFill>
-                  <a:srgbClr val="6D28D9"/>
+                  <a:srgbClr val="F26522"/>
                 </a:solidFill>
                 <a:latin typeface="Calibri"/>
               </a:rPr>
@@ -9727,7 +9771,7 @@
             <a:r>
               <a:rPr sz="1100">
                 <a:solidFill>
-                  <a:srgbClr val="1F2937"/>
+                  <a:srgbClr val="1F242C"/>
                 </a:solidFill>
                 <a:latin typeface="Calibri"/>
               </a:rPr>
@@ -9746,7 +9790,7 @@
             <a:r>
               <a:rPr sz="1100" b="1">
                 <a:solidFill>
-                  <a:srgbClr val="6D28D9"/>
+                  <a:srgbClr val="F26522"/>
                 </a:solidFill>
                 <a:latin typeface="Calibri"/>
               </a:rPr>
@@ -9755,7 +9799,7 @@
             <a:r>
               <a:rPr sz="1100">
                 <a:solidFill>
-                  <a:srgbClr val="1F2937"/>
+                  <a:srgbClr val="1F242C"/>
                 </a:solidFill>
                 <a:latin typeface="Calibri"/>
               </a:rPr>
@@ -9781,11 +9825,11 @@
             </a:avLst>
           </a:prstGeom>
           <a:solidFill>
-            <a:srgbClr val="F7F9FC"/>
+            <a:srgbClr val="F7F7F8"/>
           </a:solidFill>
           <a:ln w="9525">
             <a:solidFill>
-              <a:srgbClr val="E2E8F0"/>
+              <a:srgbClr val="E3E6EB"/>
             </a:solidFill>
           </a:ln>
           <a:effectLst/>
@@ -9829,7 +9873,7 @@
             </a:avLst>
           </a:prstGeom>
           <a:solidFill>
-            <a:srgbClr val="EDE9FE"/>
+            <a:srgbClr val="FFECDF"/>
           </a:solidFill>
           <a:ln>
             <a:noFill/>
@@ -9888,7 +9932,7 @@
             <a:r>
               <a:rPr sz="900" b="1">
                 <a:solidFill>
-                  <a:srgbClr val="6D28D9"/>
+                  <a:srgbClr val="F26522"/>
                 </a:solidFill>
                 <a:latin typeface="Calibri"/>
               </a:rPr>
@@ -9927,7 +9971,7 @@
             <a:r>
               <a:rPr sz="1500" b="1">
                 <a:solidFill>
-                  <a:srgbClr val="0B1F3A"/>
+                  <a:srgbClr val="111418"/>
                 </a:solidFill>
                 <a:latin typeface="Calibri"/>
               </a:rPr>
@@ -9969,7 +10013,7 @@
             <a:r>
               <a:rPr sz="1100" b="1">
                 <a:solidFill>
-                  <a:srgbClr val="6D28D9"/>
+                  <a:srgbClr val="F26522"/>
                 </a:solidFill>
                 <a:latin typeface="Calibri"/>
               </a:rPr>
@@ -9978,7 +10022,7 @@
             <a:r>
               <a:rPr sz="1100">
                 <a:solidFill>
-                  <a:srgbClr val="1F2937"/>
+                  <a:srgbClr val="1F242C"/>
                 </a:solidFill>
                 <a:latin typeface="Calibri"/>
               </a:rPr>
@@ -9997,7 +10041,7 @@
             <a:r>
               <a:rPr sz="1100" b="1">
                 <a:solidFill>
-                  <a:srgbClr val="6D28D9"/>
+                  <a:srgbClr val="F26522"/>
                 </a:solidFill>
                 <a:latin typeface="Calibri"/>
               </a:rPr>
@@ -10006,7 +10050,7 @@
             <a:r>
               <a:rPr sz="1100">
                 <a:solidFill>
-                  <a:srgbClr val="1F2937"/>
+                  <a:srgbClr val="1F242C"/>
                 </a:solidFill>
                 <a:latin typeface="Calibri"/>
               </a:rPr>
@@ -10025,7 +10069,7 @@
             <a:r>
               <a:rPr sz="1100" b="1">
                 <a:solidFill>
-                  <a:srgbClr val="6D28D9"/>
+                  <a:srgbClr val="F26522"/>
                 </a:solidFill>
                 <a:latin typeface="Calibri"/>
               </a:rPr>
@@ -10034,7 +10078,7 @@
             <a:r>
               <a:rPr sz="1100">
                 <a:solidFill>
-                  <a:srgbClr val="1F2937"/>
+                  <a:srgbClr val="1F242C"/>
                 </a:solidFill>
                 <a:latin typeface="Calibri"/>
               </a:rPr>
@@ -10053,7 +10097,7 @@
             <a:r>
               <a:rPr sz="1100" b="1">
                 <a:solidFill>
-                  <a:srgbClr val="6D28D9"/>
+                  <a:srgbClr val="F26522"/>
                 </a:solidFill>
                 <a:latin typeface="Calibri"/>
               </a:rPr>
@@ -10062,7 +10106,7 @@
             <a:r>
               <a:rPr sz="1100">
                 <a:solidFill>
-                  <a:srgbClr val="1F2937"/>
+                  <a:srgbClr val="1F242C"/>
                 </a:solidFill>
                 <a:latin typeface="Calibri"/>
               </a:rPr>
@@ -10081,7 +10125,7 @@
             <a:r>
               <a:rPr sz="1100" b="1">
                 <a:solidFill>
-                  <a:srgbClr val="6D28D9"/>
+                  <a:srgbClr val="F26522"/>
                 </a:solidFill>
                 <a:latin typeface="Calibri"/>
               </a:rPr>
@@ -10090,7 +10134,7 @@
             <a:r>
               <a:rPr sz="1100">
                 <a:solidFill>
-                  <a:srgbClr val="1F2937"/>
+                  <a:srgbClr val="1F242C"/>
                 </a:solidFill>
                 <a:latin typeface="Calibri"/>
               </a:rPr>
@@ -10132,7 +10176,7 @@
             <a:avLst/>
           </a:prstGeom>
           <a:solidFill>
-            <a:srgbClr val="6D28D9"/>
+            <a:srgbClr val="F26522"/>
           </a:solidFill>
           <a:ln>
             <a:noFill/>
@@ -10191,7 +10235,7 @@
             <a:r>
               <a:rPr sz="1000" b="1">
                 <a:solidFill>
-                  <a:srgbClr val="6D28D9"/>
+                  <a:srgbClr val="F26522"/>
                 </a:solidFill>
                 <a:latin typeface="Calibri"/>
               </a:rPr>
@@ -10230,7 +10274,7 @@
             <a:r>
               <a:rPr sz="2600" b="1">
                 <a:solidFill>
-                  <a:srgbClr val="0B1F3A"/>
+                  <a:srgbClr val="111418"/>
                 </a:solidFill>
                 <a:latin typeface="Calibri"/>
               </a:rPr>
@@ -10254,7 +10298,7 @@
             <a:avLst/>
           </a:prstGeom>
           <a:solidFill>
-            <a:srgbClr val="0B1F3A"/>
+            <a:srgbClr val="111418"/>
           </a:solidFill>
           <a:ln>
             <a:noFill/>
@@ -10378,11 +10422,11 @@
             </a:avLst>
           </a:prstGeom>
           <a:solidFill>
-            <a:srgbClr val="F7F9FC"/>
+            <a:srgbClr val="F7F7F8"/>
           </a:solidFill>
           <a:ln>
             <a:solidFill>
-              <a:srgbClr val="E2E8F0"/>
+              <a:srgbClr val="E3E6EB"/>
             </a:solidFill>
           </a:ln>
           <a:effectLst/>
@@ -10439,7 +10483,7 @@
             <a:r>
               <a:rPr sz="2200" b="1">
                 <a:solidFill>
-                  <a:srgbClr val="6D28D9"/>
+                  <a:srgbClr val="F26522"/>
                 </a:solidFill>
                 <a:latin typeface="Calibri"/>
               </a:rPr>
@@ -10478,7 +10522,7 @@
             <a:r>
               <a:rPr sz="1500" b="1">
                 <a:solidFill>
-                  <a:srgbClr val="0B1F3A"/>
+                  <a:srgbClr val="111418"/>
                 </a:solidFill>
                 <a:latin typeface="Calibri"/>
               </a:rPr>
@@ -10502,7 +10546,7 @@
             <a:avLst/>
           </a:prstGeom>
           <a:solidFill>
-            <a:srgbClr val="6D28D9"/>
+            <a:srgbClr val="F26522"/>
           </a:solidFill>
           <a:ln>
             <a:noFill/>
@@ -10564,7 +10608,7 @@
             <a:r>
               <a:rPr sz="1100" b="1">
                 <a:solidFill>
-                  <a:srgbClr val="6D28D9"/>
+                  <a:srgbClr val="F26522"/>
                 </a:solidFill>
                 <a:latin typeface="Calibri"/>
               </a:rPr>
@@ -10573,7 +10617,7 @@
             <a:r>
               <a:rPr sz="1100">
                 <a:solidFill>
-                  <a:srgbClr val="1F2937"/>
+                  <a:srgbClr val="1F242C"/>
                 </a:solidFill>
                 <a:latin typeface="Calibri"/>
               </a:rPr>
@@ -10592,7 +10636,7 @@
             <a:r>
               <a:rPr sz="1100" b="1">
                 <a:solidFill>
-                  <a:srgbClr val="6D28D9"/>
+                  <a:srgbClr val="F26522"/>
                 </a:solidFill>
                 <a:latin typeface="Calibri"/>
               </a:rPr>
@@ -10601,7 +10645,7 @@
             <a:r>
               <a:rPr sz="1100">
                 <a:solidFill>
-                  <a:srgbClr val="1F2937"/>
+                  <a:srgbClr val="1F242C"/>
                 </a:solidFill>
                 <a:latin typeface="Calibri"/>
               </a:rPr>
@@ -10620,7 +10664,7 @@
             <a:r>
               <a:rPr sz="1100" b="1">
                 <a:solidFill>
-                  <a:srgbClr val="6D28D9"/>
+                  <a:srgbClr val="F26522"/>
                 </a:solidFill>
                 <a:latin typeface="Calibri"/>
               </a:rPr>
@@ -10629,7 +10673,7 @@
             <a:r>
               <a:rPr sz="1100">
                 <a:solidFill>
-                  <a:srgbClr val="1F2937"/>
+                  <a:srgbClr val="1F242C"/>
                 </a:solidFill>
                 <a:latin typeface="Calibri"/>
               </a:rPr>
@@ -10655,11 +10699,11 @@
             </a:avLst>
           </a:prstGeom>
           <a:solidFill>
-            <a:srgbClr val="F7F9FC"/>
+            <a:srgbClr val="F7F7F8"/>
           </a:solidFill>
           <a:ln>
             <a:solidFill>
-              <a:srgbClr val="E2E8F0"/>
+              <a:srgbClr val="E3E6EB"/>
             </a:solidFill>
           </a:ln>
           <a:effectLst/>
@@ -10716,7 +10760,7 @@
             <a:r>
               <a:rPr sz="2200" b="1">
                 <a:solidFill>
-                  <a:srgbClr val="6D28D9"/>
+                  <a:srgbClr val="F26522"/>
                 </a:solidFill>
                 <a:latin typeface="Calibri"/>
               </a:rPr>
@@ -10755,7 +10799,7 @@
             <a:r>
               <a:rPr sz="1500" b="1">
                 <a:solidFill>
-                  <a:srgbClr val="0B1F3A"/>
+                  <a:srgbClr val="111418"/>
                 </a:solidFill>
                 <a:latin typeface="Calibri"/>
               </a:rPr>
@@ -10779,7 +10823,7 @@
             <a:avLst/>
           </a:prstGeom>
           <a:solidFill>
-            <a:srgbClr val="6D28D9"/>
+            <a:srgbClr val="F26522"/>
           </a:solidFill>
           <a:ln>
             <a:noFill/>
@@ -10841,7 +10885,7 @@
             <a:r>
               <a:rPr sz="1100" b="1">
                 <a:solidFill>
-                  <a:srgbClr val="6D28D9"/>
+                  <a:srgbClr val="F26522"/>
                 </a:solidFill>
                 <a:latin typeface="Calibri"/>
               </a:rPr>
@@ -10850,7 +10894,7 @@
             <a:r>
               <a:rPr sz="1100">
                 <a:solidFill>
-                  <a:srgbClr val="1F2937"/>
+                  <a:srgbClr val="1F242C"/>
                 </a:solidFill>
                 <a:latin typeface="Calibri"/>
               </a:rPr>
@@ -10869,7 +10913,7 @@
             <a:r>
               <a:rPr sz="1100" b="1">
                 <a:solidFill>
-                  <a:srgbClr val="6D28D9"/>
+                  <a:srgbClr val="F26522"/>
                 </a:solidFill>
                 <a:latin typeface="Calibri"/>
               </a:rPr>
@@ -10878,7 +10922,7 @@
             <a:r>
               <a:rPr sz="1100">
                 <a:solidFill>
-                  <a:srgbClr val="1F2937"/>
+                  <a:srgbClr val="1F242C"/>
                 </a:solidFill>
                 <a:latin typeface="Calibri"/>
               </a:rPr>
@@ -10897,7 +10941,7 @@
             <a:r>
               <a:rPr sz="1100" b="1">
                 <a:solidFill>
-                  <a:srgbClr val="6D28D9"/>
+                  <a:srgbClr val="F26522"/>
                 </a:solidFill>
                 <a:latin typeface="Calibri"/>
               </a:rPr>
@@ -10906,7 +10950,7 @@
             <a:r>
               <a:rPr sz="1100">
                 <a:solidFill>
-                  <a:srgbClr val="1F2937"/>
+                  <a:srgbClr val="1F242C"/>
                 </a:solidFill>
                 <a:latin typeface="Calibri"/>
               </a:rPr>
@@ -10932,11 +10976,11 @@
             </a:avLst>
           </a:prstGeom>
           <a:solidFill>
-            <a:srgbClr val="F7F9FC"/>
+            <a:srgbClr val="F7F7F8"/>
           </a:solidFill>
           <a:ln>
             <a:solidFill>
-              <a:srgbClr val="E2E8F0"/>
+              <a:srgbClr val="E3E6EB"/>
             </a:solidFill>
           </a:ln>
           <a:effectLst/>
@@ -10993,7 +11037,7 @@
             <a:r>
               <a:rPr sz="2200" b="1">
                 <a:solidFill>
-                  <a:srgbClr val="6D28D9"/>
+                  <a:srgbClr val="F26522"/>
                 </a:solidFill>
                 <a:latin typeface="Calibri"/>
               </a:rPr>
@@ -11032,7 +11076,7 @@
             <a:r>
               <a:rPr sz="1500" b="1">
                 <a:solidFill>
-                  <a:srgbClr val="0B1F3A"/>
+                  <a:srgbClr val="111418"/>
                 </a:solidFill>
                 <a:latin typeface="Calibri"/>
               </a:rPr>
@@ -11056,7 +11100,7 @@
             <a:avLst/>
           </a:prstGeom>
           <a:solidFill>
-            <a:srgbClr val="6D28D9"/>
+            <a:srgbClr val="F26522"/>
           </a:solidFill>
           <a:ln>
             <a:noFill/>
@@ -11118,7 +11162,7 @@
             <a:r>
               <a:rPr sz="1100" b="1">
                 <a:solidFill>
-                  <a:srgbClr val="6D28D9"/>
+                  <a:srgbClr val="F26522"/>
                 </a:solidFill>
                 <a:latin typeface="Calibri"/>
               </a:rPr>
@@ -11127,7 +11171,7 @@
             <a:r>
               <a:rPr sz="1100">
                 <a:solidFill>
-                  <a:srgbClr val="1F2937"/>
+                  <a:srgbClr val="1F242C"/>
                 </a:solidFill>
                 <a:latin typeface="Calibri"/>
               </a:rPr>
@@ -11146,7 +11190,7 @@
             <a:r>
               <a:rPr sz="1100" b="1">
                 <a:solidFill>
-                  <a:srgbClr val="6D28D9"/>
+                  <a:srgbClr val="F26522"/>
                 </a:solidFill>
                 <a:latin typeface="Calibri"/>
               </a:rPr>
@@ -11155,7 +11199,7 @@
             <a:r>
               <a:rPr sz="1100">
                 <a:solidFill>
-                  <a:srgbClr val="1F2937"/>
+                  <a:srgbClr val="1F242C"/>
                 </a:solidFill>
                 <a:latin typeface="Calibri"/>
               </a:rPr>
@@ -11174,7 +11218,7 @@
             <a:r>
               <a:rPr sz="1100" b="1">
                 <a:solidFill>
-                  <a:srgbClr val="6D28D9"/>
+                  <a:srgbClr val="F26522"/>
                 </a:solidFill>
                 <a:latin typeface="Calibri"/>
               </a:rPr>
@@ -11183,7 +11227,7 @@
             <a:r>
               <a:rPr sz="1100">
                 <a:solidFill>
-                  <a:srgbClr val="1F2937"/>
+                  <a:srgbClr val="1F242C"/>
                 </a:solidFill>
                 <a:latin typeface="Calibri"/>
               </a:rPr>
@@ -11209,11 +11253,11 @@
             </a:avLst>
           </a:prstGeom>
           <a:solidFill>
-            <a:srgbClr val="F7F9FC"/>
+            <a:srgbClr val="F7F7F8"/>
           </a:solidFill>
           <a:ln>
             <a:solidFill>
-              <a:srgbClr val="E2E8F0"/>
+              <a:srgbClr val="E3E6EB"/>
             </a:solidFill>
           </a:ln>
           <a:effectLst/>
@@ -11270,7 +11314,7 @@
             <a:r>
               <a:rPr sz="2200" b="1">
                 <a:solidFill>
-                  <a:srgbClr val="6D28D9"/>
+                  <a:srgbClr val="F26522"/>
                 </a:solidFill>
                 <a:latin typeface="Calibri"/>
               </a:rPr>
@@ -11309,7 +11353,7 @@
             <a:r>
               <a:rPr sz="1500" b="1">
                 <a:solidFill>
-                  <a:srgbClr val="0B1F3A"/>
+                  <a:srgbClr val="111418"/>
                 </a:solidFill>
                 <a:latin typeface="Calibri"/>
               </a:rPr>
@@ -11333,7 +11377,7 @@
             <a:avLst/>
           </a:prstGeom>
           <a:solidFill>
-            <a:srgbClr val="6D28D9"/>
+            <a:srgbClr val="F26522"/>
           </a:solidFill>
           <a:ln>
             <a:noFill/>
@@ -11395,7 +11439,7 @@
             <a:r>
               <a:rPr sz="1100" b="1">
                 <a:solidFill>
-                  <a:srgbClr val="6D28D9"/>
+                  <a:srgbClr val="F26522"/>
                 </a:solidFill>
                 <a:latin typeface="Calibri"/>
               </a:rPr>
@@ -11404,7 +11448,7 @@
             <a:r>
               <a:rPr sz="1100">
                 <a:solidFill>
-                  <a:srgbClr val="1F2937"/>
+                  <a:srgbClr val="1F242C"/>
                 </a:solidFill>
                 <a:latin typeface="Calibri"/>
               </a:rPr>
@@ -11423,7 +11467,7 @@
             <a:r>
               <a:rPr sz="1100" b="1">
                 <a:solidFill>
-                  <a:srgbClr val="6D28D9"/>
+                  <a:srgbClr val="F26522"/>
                 </a:solidFill>
                 <a:latin typeface="Calibri"/>
               </a:rPr>
@@ -11432,7 +11476,7 @@
             <a:r>
               <a:rPr sz="1100">
                 <a:solidFill>
-                  <a:srgbClr val="1F2937"/>
+                  <a:srgbClr val="1F242C"/>
                 </a:solidFill>
                 <a:latin typeface="Calibri"/>
               </a:rPr>
@@ -11451,7 +11495,7 @@
             <a:r>
               <a:rPr sz="1100" b="1">
                 <a:solidFill>
-                  <a:srgbClr val="6D28D9"/>
+                  <a:srgbClr val="F26522"/>
                 </a:solidFill>
                 <a:latin typeface="Calibri"/>
               </a:rPr>
@@ -11460,7 +11504,7 @@
             <a:r>
               <a:rPr sz="1100">
                 <a:solidFill>
-                  <a:srgbClr val="1F2937"/>
+                  <a:srgbClr val="1F242C"/>
                 </a:solidFill>
                 <a:latin typeface="Calibri"/>
               </a:rPr>
@@ -11502,7 +11546,7 @@
             <a:avLst/>
           </a:prstGeom>
           <a:solidFill>
-            <a:srgbClr val="6D28D9"/>
+            <a:srgbClr val="F26522"/>
           </a:solidFill>
           <a:ln>
             <a:noFill/>
@@ -11561,7 +11605,7 @@
             <a:r>
               <a:rPr sz="1000" b="1">
                 <a:solidFill>
-                  <a:srgbClr val="6D28D9"/>
+                  <a:srgbClr val="F26522"/>
                 </a:solidFill>
                 <a:latin typeface="Calibri"/>
               </a:rPr>
@@ -11600,7 +11644,7 @@
             <a:r>
               <a:rPr sz="2600" b="1">
                 <a:solidFill>
-                  <a:srgbClr val="0B1F3A"/>
+                  <a:srgbClr val="111418"/>
                 </a:solidFill>
                 <a:latin typeface="Calibri"/>
               </a:rPr>
@@ -11624,7 +11668,7 @@
             <a:avLst/>
           </a:prstGeom>
           <a:solidFill>
-            <a:srgbClr val="0B1F3A"/>
+            <a:srgbClr val="111418"/>
           </a:solidFill>
           <a:ln>
             <a:noFill/>
@@ -11785,7 +11829,7 @@
             <a:avLst/>
           </a:prstGeom>
           <a:solidFill>
-            <a:srgbClr val="EDE9FE"/>
+            <a:srgbClr val="FFECDF"/>
           </a:solidFill>
           <a:ln>
             <a:noFill/>
@@ -11844,7 +11888,7 @@
             <a:r>
               <a:rPr sz="1000" b="1">
                 <a:solidFill>
-                  <a:srgbClr val="6D28D9"/>
+                  <a:srgbClr val="F26522"/>
                 </a:solidFill>
                 <a:latin typeface="Calibri"/>
               </a:rPr>
@@ -11883,7 +11927,7 @@
             <a:r>
               <a:rPr sz="1600" b="1">
                 <a:solidFill>
-                  <a:srgbClr val="0B1F3A"/>
+                  <a:srgbClr val="111418"/>
                 </a:solidFill>
                 <a:latin typeface="Calibri"/>
               </a:rPr>
@@ -11922,7 +11966,7 @@
             <a:r>
               <a:rPr sz="1200" b="0">
                 <a:solidFill>
-                  <a:srgbClr val="1F2937"/>
+                  <a:srgbClr val="1F242C"/>
                 </a:solidFill>
                 <a:latin typeface="Calibri"/>
               </a:rPr>
@@ -11946,7 +11990,7 @@
             <a:avLst/>
           </a:prstGeom>
           <a:solidFill>
-            <a:srgbClr val="E2E8F0"/>
+            <a:srgbClr val="E3E6EB"/>
           </a:solidFill>
           <a:ln>
             <a:noFill/>
@@ -11990,7 +12034,7 @@
             <a:avLst/>
           </a:prstGeom>
           <a:solidFill>
-            <a:srgbClr val="EDE9FE"/>
+            <a:srgbClr val="FFECDF"/>
           </a:solidFill>
           <a:ln>
             <a:noFill/>
@@ -12049,7 +12093,7 @@
             <a:r>
               <a:rPr sz="1000" b="1">
                 <a:solidFill>
-                  <a:srgbClr val="6D28D9"/>
+                  <a:srgbClr val="F26522"/>
                 </a:solidFill>
                 <a:latin typeface="Calibri"/>
               </a:rPr>
@@ -12088,7 +12132,7 @@
             <a:r>
               <a:rPr sz="1600" b="1">
                 <a:solidFill>
-                  <a:srgbClr val="0B1F3A"/>
+                  <a:srgbClr val="111418"/>
                 </a:solidFill>
                 <a:latin typeface="Calibri"/>
               </a:rPr>
@@ -12127,7 +12171,7 @@
             <a:r>
               <a:rPr sz="1200" b="0">
                 <a:solidFill>
-                  <a:srgbClr val="1F2937"/>
+                  <a:srgbClr val="1F242C"/>
                 </a:solidFill>
                 <a:latin typeface="Calibri"/>
               </a:rPr>
@@ -12151,7 +12195,7 @@
             <a:avLst/>
           </a:prstGeom>
           <a:solidFill>
-            <a:srgbClr val="E2E8F0"/>
+            <a:srgbClr val="E3E6EB"/>
           </a:solidFill>
           <a:ln>
             <a:noFill/>
@@ -12195,7 +12239,7 @@
             <a:avLst/>
           </a:prstGeom>
           <a:solidFill>
-            <a:srgbClr val="EDE9FE"/>
+            <a:srgbClr val="FFECDF"/>
           </a:solidFill>
           <a:ln>
             <a:noFill/>
@@ -12254,7 +12298,7 @@
             <a:r>
               <a:rPr sz="1000" b="1">
                 <a:solidFill>
-                  <a:srgbClr val="6D28D9"/>
+                  <a:srgbClr val="F26522"/>
                 </a:solidFill>
                 <a:latin typeface="Calibri"/>
               </a:rPr>
@@ -12293,7 +12337,7 @@
             <a:r>
               <a:rPr sz="1600" b="1">
                 <a:solidFill>
-                  <a:srgbClr val="0B1F3A"/>
+                  <a:srgbClr val="111418"/>
                 </a:solidFill>
                 <a:latin typeface="Calibri"/>
               </a:rPr>
@@ -12332,7 +12376,7 @@
             <a:r>
               <a:rPr sz="1200" b="0">
                 <a:solidFill>
-                  <a:srgbClr val="1F2937"/>
+                  <a:srgbClr val="1F242C"/>
                 </a:solidFill>
                 <a:latin typeface="Calibri"/>
               </a:rPr>
@@ -12356,7 +12400,7 @@
             <a:avLst/>
           </a:prstGeom>
           <a:solidFill>
-            <a:srgbClr val="E2E8F0"/>
+            <a:srgbClr val="E3E6EB"/>
           </a:solidFill>
           <a:ln>
             <a:noFill/>
@@ -12400,7 +12444,7 @@
             <a:avLst/>
           </a:prstGeom>
           <a:solidFill>
-            <a:srgbClr val="EDE9FE"/>
+            <a:srgbClr val="FFECDF"/>
           </a:solidFill>
           <a:ln>
             <a:noFill/>
@@ -12459,7 +12503,7 @@
             <a:r>
               <a:rPr sz="1000" b="1">
                 <a:solidFill>
-                  <a:srgbClr val="6D28D9"/>
+                  <a:srgbClr val="F26522"/>
                 </a:solidFill>
                 <a:latin typeface="Calibri"/>
               </a:rPr>
@@ -12498,7 +12542,7 @@
             <a:r>
               <a:rPr sz="1600" b="1">
                 <a:solidFill>
-                  <a:srgbClr val="0B1F3A"/>
+                  <a:srgbClr val="111418"/>
                 </a:solidFill>
                 <a:latin typeface="Calibri"/>
               </a:rPr>
@@ -12537,7 +12581,7 @@
             <a:r>
               <a:rPr sz="1200" b="0">
                 <a:solidFill>
-                  <a:srgbClr val="1F2937"/>
+                  <a:srgbClr val="1F242C"/>
                 </a:solidFill>
                 <a:latin typeface="Calibri"/>
               </a:rPr>
@@ -12561,7 +12605,7 @@
             <a:avLst/>
           </a:prstGeom>
           <a:solidFill>
-            <a:srgbClr val="E2E8F0"/>
+            <a:srgbClr val="E3E6EB"/>
           </a:solidFill>
           <a:ln>
             <a:noFill/>
@@ -12623,7 +12667,7 @@
             <a:avLst/>
           </a:prstGeom>
           <a:solidFill>
-            <a:srgbClr val="6D28D9"/>
+            <a:srgbClr val="F26522"/>
           </a:solidFill>
           <a:ln>
             <a:noFill/>
@@ -12682,7 +12726,7 @@
             <a:r>
               <a:rPr sz="1000" b="1">
                 <a:solidFill>
-                  <a:srgbClr val="6D28D9"/>
+                  <a:srgbClr val="F26522"/>
                 </a:solidFill>
                 <a:latin typeface="Calibri"/>
               </a:rPr>
@@ -12721,7 +12765,7 @@
             <a:r>
               <a:rPr sz="2600" b="1">
                 <a:solidFill>
-                  <a:srgbClr val="0B1F3A"/>
+                  <a:srgbClr val="111418"/>
                 </a:solidFill>
                 <a:latin typeface="Calibri"/>
               </a:rPr>
@@ -12745,7 +12789,7 @@
             <a:avLst/>
           </a:prstGeom>
           <a:solidFill>
-            <a:srgbClr val="0B1F3A"/>
+            <a:srgbClr val="111418"/>
           </a:solidFill>
           <a:ln>
             <a:noFill/>
@@ -12908,11 +12952,11 @@
             </a:avLst>
           </a:prstGeom>
           <a:solidFill>
-            <a:srgbClr val="F7F9FC"/>
+            <a:srgbClr val="F7F7F8"/>
           </a:solidFill>
           <a:ln w="9525">
             <a:solidFill>
-              <a:srgbClr val="E2E8F0"/>
+              <a:srgbClr val="E3E6EB"/>
             </a:solidFill>
           </a:ln>
           <a:effectLst/>
@@ -12956,7 +13000,7 @@
             </a:avLst>
           </a:prstGeom>
           <a:solidFill>
-            <a:srgbClr val="EDE9FE"/>
+            <a:srgbClr val="FFECDF"/>
           </a:solidFill>
           <a:ln>
             <a:noFill/>
@@ -13015,7 +13059,7 @@
             <a:r>
               <a:rPr sz="900" b="1">
                 <a:solidFill>
-                  <a:srgbClr val="6D28D9"/>
+                  <a:srgbClr val="F26522"/>
                 </a:solidFill>
                 <a:latin typeface="Calibri"/>
               </a:rPr>
@@ -13054,7 +13098,7 @@
             <a:r>
               <a:rPr sz="1500" b="1">
                 <a:solidFill>
-                  <a:srgbClr val="0B1F3A"/>
+                  <a:srgbClr val="111418"/>
                 </a:solidFill>
                 <a:latin typeface="Calibri"/>
               </a:rPr>
@@ -13096,7 +13140,7 @@
             <a:r>
               <a:rPr sz="1100" b="1">
                 <a:solidFill>
-                  <a:srgbClr val="6D28D9"/>
+                  <a:srgbClr val="F26522"/>
                 </a:solidFill>
                 <a:latin typeface="Calibri"/>
               </a:rPr>
@@ -13105,7 +13149,7 @@
             <a:r>
               <a:rPr sz="1100">
                 <a:solidFill>
-                  <a:srgbClr val="1F2937"/>
+                  <a:srgbClr val="1F242C"/>
                 </a:solidFill>
                 <a:latin typeface="Calibri"/>
               </a:rPr>
@@ -13124,7 +13168,7 @@
             <a:r>
               <a:rPr sz="1100" b="1">
                 <a:solidFill>
-                  <a:srgbClr val="6D28D9"/>
+                  <a:srgbClr val="F26522"/>
                 </a:solidFill>
                 <a:latin typeface="Calibri"/>
               </a:rPr>
@@ -13133,7 +13177,7 @@
             <a:r>
               <a:rPr sz="1100">
                 <a:solidFill>
-                  <a:srgbClr val="1F2937"/>
+                  <a:srgbClr val="1F242C"/>
                 </a:solidFill>
                 <a:latin typeface="Calibri"/>
               </a:rPr>
@@ -13152,7 +13196,7 @@
             <a:r>
               <a:rPr sz="1100" b="1">
                 <a:solidFill>
-                  <a:srgbClr val="6D28D9"/>
+                  <a:srgbClr val="F26522"/>
                 </a:solidFill>
                 <a:latin typeface="Calibri"/>
               </a:rPr>
@@ -13161,7 +13205,7 @@
             <a:r>
               <a:rPr sz="1100">
                 <a:solidFill>
-                  <a:srgbClr val="1F2937"/>
+                  <a:srgbClr val="1F242C"/>
                 </a:solidFill>
                 <a:latin typeface="Calibri"/>
               </a:rPr>
@@ -13180,7 +13224,7 @@
             <a:r>
               <a:rPr sz="1100" b="1">
                 <a:solidFill>
-                  <a:srgbClr val="6D28D9"/>
+                  <a:srgbClr val="F26522"/>
                 </a:solidFill>
                 <a:latin typeface="Calibri"/>
               </a:rPr>
@@ -13189,7 +13233,7 @@
             <a:r>
               <a:rPr sz="1100">
                 <a:solidFill>
-                  <a:srgbClr val="1F2937"/>
+                  <a:srgbClr val="1F242C"/>
                 </a:solidFill>
                 <a:latin typeface="Calibri"/>
               </a:rPr>
@@ -13215,11 +13259,11 @@
             </a:avLst>
           </a:prstGeom>
           <a:solidFill>
-            <a:srgbClr val="F7F9FC"/>
+            <a:srgbClr val="F7F7F8"/>
           </a:solidFill>
           <a:ln w="9525">
             <a:solidFill>
-              <a:srgbClr val="E2E8F0"/>
+              <a:srgbClr val="E3E6EB"/>
             </a:solidFill>
           </a:ln>
           <a:effectLst/>
@@ -13263,7 +13307,7 @@
             </a:avLst>
           </a:prstGeom>
           <a:solidFill>
-            <a:srgbClr val="EDE9FE"/>
+            <a:srgbClr val="FFECDF"/>
           </a:solidFill>
           <a:ln>
             <a:noFill/>
@@ -13322,7 +13366,7 @@
             <a:r>
               <a:rPr sz="900" b="1">
                 <a:solidFill>
-                  <a:srgbClr val="6D28D9"/>
+                  <a:srgbClr val="F26522"/>
                 </a:solidFill>
                 <a:latin typeface="Calibri"/>
               </a:rPr>
@@ -13361,7 +13405,7 @@
             <a:r>
               <a:rPr sz="1500" b="1">
                 <a:solidFill>
-                  <a:srgbClr val="0B1F3A"/>
+                  <a:srgbClr val="111418"/>
                 </a:solidFill>
                 <a:latin typeface="Calibri"/>
               </a:rPr>
@@ -13403,7 +13447,7 @@
             <a:r>
               <a:rPr sz="1100" b="1">
                 <a:solidFill>
-                  <a:srgbClr val="6D28D9"/>
+                  <a:srgbClr val="F26522"/>
                 </a:solidFill>
                 <a:latin typeface="Calibri"/>
               </a:rPr>
@@ -13412,7 +13456,7 @@
             <a:r>
               <a:rPr sz="1100">
                 <a:solidFill>
-                  <a:srgbClr val="1F2937"/>
+                  <a:srgbClr val="1F242C"/>
                 </a:solidFill>
                 <a:latin typeface="Calibri"/>
               </a:rPr>
@@ -13431,7 +13475,7 @@
             <a:r>
               <a:rPr sz="1100" b="1">
                 <a:solidFill>
-                  <a:srgbClr val="6D28D9"/>
+                  <a:srgbClr val="F26522"/>
                 </a:solidFill>
                 <a:latin typeface="Calibri"/>
               </a:rPr>
@@ -13440,7 +13484,7 @@
             <a:r>
               <a:rPr sz="1100">
                 <a:solidFill>
-                  <a:srgbClr val="1F2937"/>
+                  <a:srgbClr val="1F242C"/>
                 </a:solidFill>
                 <a:latin typeface="Calibri"/>
               </a:rPr>
@@ -13459,7 +13503,7 @@
             <a:r>
               <a:rPr sz="1100" b="1">
                 <a:solidFill>
-                  <a:srgbClr val="6D28D9"/>
+                  <a:srgbClr val="F26522"/>
                 </a:solidFill>
                 <a:latin typeface="Calibri"/>
               </a:rPr>
@@ -13468,7 +13512,7 @@
             <a:r>
               <a:rPr sz="1100">
                 <a:solidFill>
-                  <a:srgbClr val="1F2937"/>
+                  <a:srgbClr val="1F242C"/>
                 </a:solidFill>
                 <a:latin typeface="Calibri"/>
               </a:rPr>
@@ -13487,7 +13531,7 @@
             <a:r>
               <a:rPr sz="1100" b="1">
                 <a:solidFill>
-                  <a:srgbClr val="6D28D9"/>
+                  <a:srgbClr val="F26522"/>
                 </a:solidFill>
                 <a:latin typeface="Calibri"/>
               </a:rPr>
@@ -13496,7 +13540,7 @@
             <a:r>
               <a:rPr sz="1100">
                 <a:solidFill>
-                  <a:srgbClr val="1F2937"/>
+                  <a:srgbClr val="1F242C"/>
                 </a:solidFill>
                 <a:latin typeface="Calibri"/>
               </a:rPr>
@@ -13522,11 +13566,11 @@
             </a:avLst>
           </a:prstGeom>
           <a:solidFill>
-            <a:srgbClr val="F7F9FC"/>
+            <a:srgbClr val="F7F7F8"/>
           </a:solidFill>
           <a:ln>
             <a:solidFill>
-              <a:srgbClr val="E2E8F0"/>
+              <a:srgbClr val="E3E6EB"/>
             </a:solidFill>
           </a:ln>
           <a:effectLst/>
@@ -13583,7 +13627,7 @@
             <a:r>
               <a:rPr sz="1000" b="1">
                 <a:solidFill>
-                  <a:srgbClr val="6D28D9"/>
+                  <a:srgbClr val="F26522"/>
                 </a:solidFill>
                 <a:latin typeface="Calibri"/>
               </a:rPr>
@@ -13613,7 +13657,7 @@
           </a:solidFill>
           <a:ln>
             <a:solidFill>
-              <a:srgbClr val="E2E8F0"/>
+              <a:srgbClr val="E3E6EB"/>
             </a:solidFill>
           </a:ln>
           <a:effectLst/>
@@ -13670,7 +13714,7 @@
             <a:r>
               <a:rPr sz="1400" b="1">
                 <a:solidFill>
-                  <a:srgbClr val="6D28D9"/>
+                  <a:srgbClr val="F26522"/>
                 </a:solidFill>
                 <a:latin typeface="Calibri"/>
               </a:rPr>
@@ -13709,7 +13753,7 @@
             <a:r>
               <a:rPr sz="1000" b="1">
                 <a:solidFill>
-                  <a:srgbClr val="0B1F3A"/>
+                  <a:srgbClr val="111418"/>
                 </a:solidFill>
                 <a:latin typeface="Calibri"/>
               </a:rPr>
@@ -13778,7 +13822,7 @@
           </a:solidFill>
           <a:ln>
             <a:solidFill>
-              <a:srgbClr val="E2E8F0"/>
+              <a:srgbClr val="E3E6EB"/>
             </a:solidFill>
           </a:ln>
           <a:effectLst/>
@@ -13835,7 +13879,7 @@
             <a:r>
               <a:rPr sz="1400" b="1">
                 <a:solidFill>
-                  <a:srgbClr val="6D28D9"/>
+                  <a:srgbClr val="F26522"/>
                 </a:solidFill>
                 <a:latin typeface="Calibri"/>
               </a:rPr>
@@ -13874,7 +13918,7 @@
             <a:r>
               <a:rPr sz="1000" b="1">
                 <a:solidFill>
-                  <a:srgbClr val="0B1F3A"/>
+                  <a:srgbClr val="111418"/>
                 </a:solidFill>
                 <a:latin typeface="Calibri"/>
               </a:rPr>
@@ -13943,7 +13987,7 @@
           </a:solidFill>
           <a:ln>
             <a:solidFill>
-              <a:srgbClr val="E2E8F0"/>
+              <a:srgbClr val="E3E6EB"/>
             </a:solidFill>
           </a:ln>
           <a:effectLst/>
@@ -14000,7 +14044,7 @@
             <a:r>
               <a:rPr sz="1400" b="1">
                 <a:solidFill>
-                  <a:srgbClr val="6D28D9"/>
+                  <a:srgbClr val="F26522"/>
                 </a:solidFill>
                 <a:latin typeface="Calibri"/>
               </a:rPr>
@@ -14039,7 +14083,7 @@
             <a:r>
               <a:rPr sz="1000" b="1">
                 <a:solidFill>
-                  <a:srgbClr val="0B1F3A"/>
+                  <a:srgbClr val="111418"/>
                 </a:solidFill>
                 <a:latin typeface="Calibri"/>
               </a:rPr>
@@ -14108,7 +14152,7 @@
           </a:solidFill>
           <a:ln>
             <a:solidFill>
-              <a:srgbClr val="E2E8F0"/>
+              <a:srgbClr val="E3E6EB"/>
             </a:solidFill>
           </a:ln>
           <a:effectLst/>
@@ -14165,7 +14209,7 @@
             <a:r>
               <a:rPr sz="1400" b="1">
                 <a:solidFill>
-                  <a:srgbClr val="6D28D9"/>
+                  <a:srgbClr val="F26522"/>
                 </a:solidFill>
                 <a:latin typeface="Calibri"/>
               </a:rPr>
@@ -14204,7 +14248,7 @@
             <a:r>
               <a:rPr sz="1000" b="1">
                 <a:solidFill>
-                  <a:srgbClr val="0B1F3A"/>
+                  <a:srgbClr val="111418"/>
                 </a:solidFill>
                 <a:latin typeface="Calibri"/>
               </a:rPr>
@@ -14273,7 +14317,7 @@
           </a:solidFill>
           <a:ln>
             <a:solidFill>
-              <a:srgbClr val="E2E8F0"/>
+              <a:srgbClr val="E3E6EB"/>
             </a:solidFill>
           </a:ln>
           <a:effectLst/>
@@ -14330,7 +14374,7 @@
             <a:r>
               <a:rPr sz="1400" b="1">
                 <a:solidFill>
-                  <a:srgbClr val="6D28D9"/>
+                  <a:srgbClr val="F26522"/>
                 </a:solidFill>
                 <a:latin typeface="Calibri"/>
               </a:rPr>
@@ -14369,7 +14413,7 @@
             <a:r>
               <a:rPr sz="1000" b="1">
                 <a:solidFill>
-                  <a:srgbClr val="0B1F3A"/>
+                  <a:srgbClr val="111418"/>
                 </a:solidFill>
                 <a:latin typeface="Calibri"/>
               </a:rPr>
@@ -14438,7 +14482,7 @@
           </a:solidFill>
           <a:ln>
             <a:solidFill>
-              <a:srgbClr val="E2E8F0"/>
+              <a:srgbClr val="E3E6EB"/>
             </a:solidFill>
           </a:ln>
           <a:effectLst/>
@@ -14495,7 +14539,7 @@
             <a:r>
               <a:rPr sz="1400" b="1">
                 <a:solidFill>
-                  <a:srgbClr val="6D28D9"/>
+                  <a:srgbClr val="F26522"/>
                 </a:solidFill>
                 <a:latin typeface="Calibri"/>
               </a:rPr>
@@ -14534,7 +14578,7 @@
             <a:r>
               <a:rPr sz="1000" b="1">
                 <a:solidFill>
-                  <a:srgbClr val="0B1F3A"/>
+                  <a:srgbClr val="111418"/>
                 </a:solidFill>
                 <a:latin typeface="Calibri"/>
               </a:rPr>
@@ -14615,7 +14659,7 @@
             <a:avLst/>
           </a:prstGeom>
           <a:solidFill>
-            <a:srgbClr val="6D28D9"/>
+            <a:srgbClr val="F26522"/>
           </a:solidFill>
           <a:ln>
             <a:noFill/>
@@ -14674,7 +14718,7 @@
             <a:r>
               <a:rPr sz="1000" b="1">
                 <a:solidFill>
-                  <a:srgbClr val="6D28D9"/>
+                  <a:srgbClr val="F26522"/>
                 </a:solidFill>
                 <a:latin typeface="Calibri"/>
               </a:rPr>
@@ -14713,7 +14757,7 @@
             <a:r>
               <a:rPr sz="2600" b="1">
                 <a:solidFill>
-                  <a:srgbClr val="0B1F3A"/>
+                  <a:srgbClr val="111418"/>
                 </a:solidFill>
                 <a:latin typeface="Calibri"/>
               </a:rPr>
@@ -14737,7 +14781,7 @@
             <a:avLst/>
           </a:prstGeom>
           <a:solidFill>
-            <a:srgbClr val="0B1F3A"/>
+            <a:srgbClr val="111418"/>
           </a:solidFill>
           <a:ln>
             <a:noFill/>
@@ -14900,11 +14944,11 @@
             </a:avLst>
           </a:prstGeom>
           <a:solidFill>
-            <a:srgbClr val="F7F9FC"/>
+            <a:srgbClr val="F7F7F8"/>
           </a:solidFill>
           <a:ln>
             <a:solidFill>
-              <a:srgbClr val="E2E8F0"/>
+              <a:srgbClr val="E3E6EB"/>
             </a:solidFill>
           </a:ln>
           <a:effectLst/>
@@ -14961,7 +15005,7 @@
             <a:r>
               <a:rPr sz="1100" b="1">
                 <a:solidFill>
-                  <a:srgbClr val="6D28D9"/>
+                  <a:srgbClr val="F26522"/>
                 </a:solidFill>
                 <a:latin typeface="Calibri"/>
               </a:rPr>
@@ -15000,7 +15044,7 @@
             <a:r>
               <a:rPr sz="1800" b="1">
                 <a:solidFill>
-                  <a:srgbClr val="0B1F3A"/>
+                  <a:srgbClr val="111418"/>
                 </a:solidFill>
                 <a:latin typeface="Calibri"/>
               </a:rPr>
@@ -15026,7 +15070,7 @@
             </a:avLst>
           </a:prstGeom>
           <a:solidFill>
-            <a:srgbClr val="0B1F3A"/>
+            <a:srgbClr val="111418"/>
           </a:solidFill>
           <a:ln>
             <a:noFill/>
@@ -15124,7 +15168,7 @@
             <a:r>
               <a:rPr sz="1000" b="0">
                 <a:solidFill>
-                  <a:srgbClr val="1F2937"/>
+                  <a:srgbClr val="1F242C"/>
                 </a:solidFill>
                 <a:latin typeface="Calibri"/>
               </a:rPr>
@@ -15194,11 +15238,11 @@
             </a:avLst>
           </a:prstGeom>
           <a:solidFill>
-            <a:srgbClr val="F7F9FC"/>
+            <a:srgbClr val="F7F7F8"/>
           </a:solidFill>
           <a:ln>
             <a:solidFill>
-              <a:srgbClr val="E2E8F0"/>
+              <a:srgbClr val="E3E6EB"/>
             </a:solidFill>
           </a:ln>
           <a:effectLst/>
@@ -15255,7 +15299,7 @@
             <a:r>
               <a:rPr sz="1100" b="1">
                 <a:solidFill>
-                  <a:srgbClr val="6D28D9"/>
+                  <a:srgbClr val="F26522"/>
                 </a:solidFill>
                 <a:latin typeface="Calibri"/>
               </a:rPr>
@@ -15294,7 +15338,7 @@
             <a:r>
               <a:rPr sz="1800" b="1">
                 <a:solidFill>
-                  <a:srgbClr val="0B1F3A"/>
+                  <a:srgbClr val="111418"/>
                 </a:solidFill>
                 <a:latin typeface="Calibri"/>
               </a:rPr>
@@ -15320,7 +15364,7 @@
             </a:avLst>
           </a:prstGeom>
           <a:solidFill>
-            <a:srgbClr val="0B1F3A"/>
+            <a:srgbClr val="111418"/>
           </a:solidFill>
           <a:ln>
             <a:noFill/>
@@ -15418,7 +15462,7 @@
             <a:r>
               <a:rPr sz="1000" b="0">
                 <a:solidFill>
-                  <a:srgbClr val="1F2937"/>
+                  <a:srgbClr val="1F242C"/>
                 </a:solidFill>
                 <a:latin typeface="Calibri"/>
               </a:rPr>
@@ -15488,11 +15532,11 @@
             </a:avLst>
           </a:prstGeom>
           <a:solidFill>
-            <a:srgbClr val="F7F9FC"/>
+            <a:srgbClr val="F7F7F8"/>
           </a:solidFill>
           <a:ln>
             <a:solidFill>
-              <a:srgbClr val="E2E8F0"/>
+              <a:srgbClr val="E3E6EB"/>
             </a:solidFill>
           </a:ln>
           <a:effectLst/>
@@ -15549,7 +15593,7 @@
             <a:r>
               <a:rPr sz="1100" b="1">
                 <a:solidFill>
-                  <a:srgbClr val="6D28D9"/>
+                  <a:srgbClr val="F26522"/>
                 </a:solidFill>
                 <a:latin typeface="Calibri"/>
               </a:rPr>
@@ -15588,7 +15632,7 @@
             <a:r>
               <a:rPr sz="1800" b="1">
                 <a:solidFill>
-                  <a:srgbClr val="0B1F3A"/>
+                  <a:srgbClr val="111418"/>
                 </a:solidFill>
                 <a:latin typeface="Calibri"/>
               </a:rPr>
@@ -15614,7 +15658,7 @@
             </a:avLst>
           </a:prstGeom>
           <a:solidFill>
-            <a:srgbClr val="0B1F3A"/>
+            <a:srgbClr val="111418"/>
           </a:solidFill>
           <a:ln>
             <a:noFill/>
@@ -15712,7 +15756,7 @@
             <a:r>
               <a:rPr sz="1000" b="0">
                 <a:solidFill>
-                  <a:srgbClr val="1F2937"/>
+                  <a:srgbClr val="1F242C"/>
                 </a:solidFill>
                 <a:latin typeface="Calibri"/>
               </a:rPr>
@@ -15782,11 +15826,11 @@
             </a:avLst>
           </a:prstGeom>
           <a:solidFill>
-            <a:srgbClr val="F7F9FC"/>
+            <a:srgbClr val="F7F7F8"/>
           </a:solidFill>
           <a:ln>
             <a:solidFill>
-              <a:srgbClr val="E2E8F0"/>
+              <a:srgbClr val="E3E6EB"/>
             </a:solidFill>
           </a:ln>
           <a:effectLst/>
@@ -15843,7 +15887,7 @@
             <a:r>
               <a:rPr sz="1100" b="1">
                 <a:solidFill>
-                  <a:srgbClr val="6D28D9"/>
+                  <a:srgbClr val="F26522"/>
                 </a:solidFill>
                 <a:latin typeface="Calibri"/>
               </a:rPr>
@@ -15882,7 +15926,7 @@
             <a:r>
               <a:rPr sz="1800" b="1">
                 <a:solidFill>
-                  <a:srgbClr val="0B1F3A"/>
+                  <a:srgbClr val="111418"/>
                 </a:solidFill>
                 <a:latin typeface="Calibri"/>
               </a:rPr>
@@ -15908,7 +15952,7 @@
             </a:avLst>
           </a:prstGeom>
           <a:solidFill>
-            <a:srgbClr val="0B1F3A"/>
+            <a:srgbClr val="111418"/>
           </a:solidFill>
           <a:ln>
             <a:noFill/>
@@ -16006,7 +16050,7 @@
             <a:r>
               <a:rPr sz="1000" b="0">
                 <a:solidFill>
-                  <a:srgbClr val="1F2937"/>
+                  <a:srgbClr val="1F242C"/>
                 </a:solidFill>
                 <a:latin typeface="Calibri"/>
               </a:rPr>
@@ -16076,11 +16120,11 @@
             </a:avLst>
           </a:prstGeom>
           <a:solidFill>
-            <a:srgbClr val="F7F9FC"/>
+            <a:srgbClr val="F7F7F8"/>
           </a:solidFill>
           <a:ln>
             <a:solidFill>
-              <a:srgbClr val="E2E8F0"/>
+              <a:srgbClr val="E3E6EB"/>
             </a:solidFill>
           </a:ln>
           <a:effectLst/>
@@ -16137,7 +16181,7 @@
             <a:r>
               <a:rPr sz="1100" b="1">
                 <a:solidFill>
-                  <a:srgbClr val="6D28D9"/>
+                  <a:srgbClr val="F26522"/>
                 </a:solidFill>
                 <a:latin typeface="Calibri"/>
               </a:rPr>
@@ -16176,7 +16220,7 @@
             <a:r>
               <a:rPr sz="1800" b="1">
                 <a:solidFill>
-                  <a:srgbClr val="0B1F3A"/>
+                  <a:srgbClr val="111418"/>
                 </a:solidFill>
                 <a:latin typeface="Calibri"/>
               </a:rPr>
@@ -16202,7 +16246,7 @@
             </a:avLst>
           </a:prstGeom>
           <a:solidFill>
-            <a:srgbClr val="0B1F3A"/>
+            <a:srgbClr val="111418"/>
           </a:solidFill>
           <a:ln>
             <a:noFill/>
@@ -16300,7 +16344,7 @@
             <a:r>
               <a:rPr sz="1000" b="0">
                 <a:solidFill>
-                  <a:srgbClr val="1F2937"/>
+                  <a:srgbClr val="1F242C"/>
                 </a:solidFill>
                 <a:latin typeface="Calibri"/>
               </a:rPr>
@@ -16370,11 +16414,11 @@
             </a:avLst>
           </a:prstGeom>
           <a:solidFill>
-            <a:srgbClr val="EDE9FE"/>
+            <a:srgbClr val="FFECDF"/>
           </a:solidFill>
           <a:ln>
             <a:solidFill>
-              <a:srgbClr val="6D28D9"/>
+              <a:srgbClr val="F26522"/>
             </a:solidFill>
           </a:ln>
           <a:effectLst/>
@@ -16431,7 +16475,7 @@
             <a:r>
               <a:rPr sz="1100" b="1">
                 <a:solidFill>
-                  <a:srgbClr val="6D28D9"/>
+                  <a:srgbClr val="F26522"/>
                 </a:solidFill>
                 <a:latin typeface="Calibri"/>
               </a:rPr>
@@ -16470,7 +16514,7 @@
             <a:r>
               <a:rPr sz="1800" b="1">
                 <a:solidFill>
-                  <a:srgbClr val="0B1F3A"/>
+                  <a:srgbClr val="111418"/>
                 </a:solidFill>
                 <a:latin typeface="Calibri"/>
               </a:rPr>
@@ -16496,7 +16540,7 @@
             </a:avLst>
           </a:prstGeom>
           <a:solidFill>
-            <a:srgbClr val="0B1F3A"/>
+            <a:srgbClr val="111418"/>
           </a:solidFill>
           <a:ln>
             <a:noFill/>
@@ -16594,7 +16638,7 @@
             <a:r>
               <a:rPr sz="1000" b="0">
                 <a:solidFill>
-                  <a:srgbClr val="1F2937"/>
+                  <a:srgbClr val="1F242C"/>
                 </a:solidFill>
                 <a:latin typeface="Calibri"/>
               </a:rPr>
@@ -16620,11 +16664,11 @@
             </a:avLst>
           </a:prstGeom>
           <a:solidFill>
-            <a:srgbClr val="F7F9FC"/>
+            <a:srgbClr val="F7F7F8"/>
           </a:solidFill>
           <a:ln w="9525">
             <a:solidFill>
-              <a:srgbClr val="E2E8F0"/>
+              <a:srgbClr val="E3E6EB"/>
             </a:solidFill>
           </a:ln>
           <a:effectLst/>
@@ -16668,7 +16712,7 @@
             </a:avLst>
           </a:prstGeom>
           <a:solidFill>
-            <a:srgbClr val="EDE9FE"/>
+            <a:srgbClr val="FFECDF"/>
           </a:solidFill>
           <a:ln>
             <a:noFill/>
@@ -16727,7 +16771,7 @@
             <a:r>
               <a:rPr sz="900" b="1">
                 <a:solidFill>
-                  <a:srgbClr val="6D28D9"/>
+                  <a:srgbClr val="F26522"/>
                 </a:solidFill>
                 <a:latin typeface="Calibri"/>
               </a:rPr>
@@ -16766,7 +16810,7 @@
             <a:r>
               <a:rPr sz="1500" b="1">
                 <a:solidFill>
-                  <a:srgbClr val="0B1F3A"/>
+                  <a:srgbClr val="111418"/>
                 </a:solidFill>
                 <a:latin typeface="Calibri"/>
               </a:rPr>
@@ -16808,7 +16852,7 @@
             <a:r>
               <a:rPr sz="1100" b="1">
                 <a:solidFill>
-                  <a:srgbClr val="6D28D9"/>
+                  <a:srgbClr val="F26522"/>
                 </a:solidFill>
                 <a:latin typeface="Calibri"/>
               </a:rPr>
@@ -16817,7 +16861,7 @@
             <a:r>
               <a:rPr sz="1100">
                 <a:solidFill>
-                  <a:srgbClr val="1F2937"/>
+                  <a:srgbClr val="1F242C"/>
                 </a:solidFill>
                 <a:latin typeface="Calibri"/>
               </a:rPr>
@@ -16836,7 +16880,7 @@
             <a:r>
               <a:rPr sz="1100" b="1">
                 <a:solidFill>
-                  <a:srgbClr val="6D28D9"/>
+                  <a:srgbClr val="F26522"/>
                 </a:solidFill>
                 <a:latin typeface="Calibri"/>
               </a:rPr>
@@ -16845,7 +16889,7 @@
             <a:r>
               <a:rPr sz="1100">
                 <a:solidFill>
-                  <a:srgbClr val="1F2937"/>
+                  <a:srgbClr val="1F242C"/>
                 </a:solidFill>
                 <a:latin typeface="Calibri"/>
               </a:rPr>
@@ -16864,7 +16908,7 @@
             <a:r>
               <a:rPr sz="1100" b="1">
                 <a:solidFill>
-                  <a:srgbClr val="6D28D9"/>
+                  <a:srgbClr val="F26522"/>
                 </a:solidFill>
                 <a:latin typeface="Calibri"/>
               </a:rPr>
@@ -16873,7 +16917,7 @@
             <a:r>
               <a:rPr sz="1100">
                 <a:solidFill>
-                  <a:srgbClr val="1F2937"/>
+                  <a:srgbClr val="1F242C"/>
                 </a:solidFill>
                 <a:latin typeface="Calibri"/>
               </a:rPr>
@@ -16892,7 +16936,7 @@
             <a:r>
               <a:rPr sz="1100" b="1">
                 <a:solidFill>
-                  <a:srgbClr val="6D28D9"/>
+                  <a:srgbClr val="F26522"/>
                 </a:solidFill>
                 <a:latin typeface="Calibri"/>
               </a:rPr>
@@ -16901,7 +16945,7 @@
             <a:r>
               <a:rPr sz="1100">
                 <a:solidFill>
-                  <a:srgbClr val="1F2937"/>
+                  <a:srgbClr val="1F242C"/>
                 </a:solidFill>
                 <a:latin typeface="Calibri"/>
               </a:rPr>
@@ -16927,11 +16971,11 @@
             </a:avLst>
           </a:prstGeom>
           <a:solidFill>
-            <a:srgbClr val="F7F9FC"/>
+            <a:srgbClr val="F7F7F8"/>
           </a:solidFill>
           <a:ln w="9525">
             <a:solidFill>
-              <a:srgbClr val="E2E8F0"/>
+              <a:srgbClr val="E3E6EB"/>
             </a:solidFill>
           </a:ln>
           <a:effectLst/>
@@ -16975,7 +17019,7 @@
             </a:avLst>
           </a:prstGeom>
           <a:solidFill>
-            <a:srgbClr val="EDE9FE"/>
+            <a:srgbClr val="FFECDF"/>
           </a:solidFill>
           <a:ln>
             <a:noFill/>
@@ -17034,7 +17078,7 @@
             <a:r>
               <a:rPr sz="900" b="1">
                 <a:solidFill>
-                  <a:srgbClr val="6D28D9"/>
+                  <a:srgbClr val="F26522"/>
                 </a:solidFill>
                 <a:latin typeface="Calibri"/>
               </a:rPr>
@@ -17073,7 +17117,7 @@
             <a:r>
               <a:rPr sz="1500" b="1">
                 <a:solidFill>
-                  <a:srgbClr val="0B1F3A"/>
+                  <a:srgbClr val="111418"/>
                 </a:solidFill>
                 <a:latin typeface="Calibri"/>
               </a:rPr>
@@ -17115,7 +17159,7 @@
             <a:r>
               <a:rPr sz="1100" b="1">
                 <a:solidFill>
-                  <a:srgbClr val="6D28D9"/>
+                  <a:srgbClr val="F26522"/>
                 </a:solidFill>
                 <a:latin typeface="Calibri"/>
               </a:rPr>
@@ -17124,7 +17168,7 @@
             <a:r>
               <a:rPr sz="1100">
                 <a:solidFill>
-                  <a:srgbClr val="1F2937"/>
+                  <a:srgbClr val="1F242C"/>
                 </a:solidFill>
                 <a:latin typeface="Calibri"/>
               </a:rPr>
@@ -17143,7 +17187,7 @@
             <a:r>
               <a:rPr sz="1100" b="1">
                 <a:solidFill>
-                  <a:srgbClr val="6D28D9"/>
+                  <a:srgbClr val="F26522"/>
                 </a:solidFill>
                 <a:latin typeface="Calibri"/>
               </a:rPr>
@@ -17152,7 +17196,7 @@
             <a:r>
               <a:rPr sz="1100">
                 <a:solidFill>
-                  <a:srgbClr val="1F2937"/>
+                  <a:srgbClr val="1F242C"/>
                 </a:solidFill>
                 <a:latin typeface="Calibri"/>
               </a:rPr>
@@ -17171,7 +17215,7 @@
             <a:r>
               <a:rPr sz="1100" b="1">
                 <a:solidFill>
-                  <a:srgbClr val="6D28D9"/>
+                  <a:srgbClr val="F26522"/>
                 </a:solidFill>
                 <a:latin typeface="Calibri"/>
               </a:rPr>
@@ -17180,7 +17224,7 @@
             <a:r>
               <a:rPr sz="1100">
                 <a:solidFill>
-                  <a:srgbClr val="1F2937"/>
+                  <a:srgbClr val="1F242C"/>
                 </a:solidFill>
                 <a:latin typeface="Calibri"/>
               </a:rPr>
@@ -17199,7 +17243,7 @@
             <a:r>
               <a:rPr sz="1100" b="1">
                 <a:solidFill>
-                  <a:srgbClr val="6D28D9"/>
+                  <a:srgbClr val="F26522"/>
                 </a:solidFill>
                 <a:latin typeface="Calibri"/>
               </a:rPr>
@@ -17208,7 +17252,7 @@
             <a:r>
               <a:rPr sz="1100">
                 <a:solidFill>
-                  <a:srgbClr val="1F2937"/>
+                  <a:srgbClr val="1F242C"/>
                 </a:solidFill>
                 <a:latin typeface="Calibri"/>
               </a:rPr>
@@ -17250,7 +17294,7 @@
             <a:avLst/>
           </a:prstGeom>
           <a:solidFill>
-            <a:srgbClr val="6D28D9"/>
+            <a:srgbClr val="F26522"/>
           </a:solidFill>
           <a:ln>
             <a:noFill/>
@@ -17309,7 +17353,7 @@
             <a:r>
               <a:rPr sz="1000" b="1">
                 <a:solidFill>
-                  <a:srgbClr val="6D28D9"/>
+                  <a:srgbClr val="F26522"/>
                 </a:solidFill>
                 <a:latin typeface="Calibri"/>
               </a:rPr>
@@ -17348,7 +17392,7 @@
             <a:r>
               <a:rPr sz="2600" b="1">
                 <a:solidFill>
-                  <a:srgbClr val="0B1F3A"/>
+                  <a:srgbClr val="111418"/>
                 </a:solidFill>
                 <a:latin typeface="Calibri"/>
               </a:rPr>
@@ -17372,7 +17416,7 @@
             <a:avLst/>
           </a:prstGeom>
           <a:solidFill>
-            <a:srgbClr val="0B1F3A"/>
+            <a:srgbClr val="111418"/>
           </a:solidFill>
           <a:ln>
             <a:noFill/>
@@ -17509,7 +17553,7 @@
             <a:r>
               <a:rPr sz="900" b="1">
                 <a:solidFill>
-                  <a:srgbClr val="6D28D9"/>
+                  <a:srgbClr val="F26522"/>
                 </a:solidFill>
                 <a:latin typeface="Calibri"/>
               </a:rPr>
@@ -17535,7 +17579,7 @@
             </a:avLst>
           </a:prstGeom>
           <a:solidFill>
-            <a:srgbClr val="0B1F3A"/>
+            <a:srgbClr val="111418"/>
           </a:solidFill>
           <a:ln>
             <a:noFill/>
@@ -17872,7 +17916,7 @@
             <a:r>
               <a:rPr sz="900" b="1">
                 <a:solidFill>
-                  <a:srgbClr val="6D28D9"/>
+                  <a:srgbClr val="F26522"/>
                 </a:solidFill>
                 <a:latin typeface="Calibri"/>
               </a:rPr>
@@ -17898,11 +17942,11 @@
             </a:avLst>
           </a:prstGeom>
           <a:solidFill>
-            <a:srgbClr val="F7F9FC"/>
+            <a:srgbClr val="F7F7F8"/>
           </a:solidFill>
           <a:ln>
             <a:solidFill>
-              <a:srgbClr val="E2E8F0"/>
+              <a:srgbClr val="E3E6EB"/>
             </a:solidFill>
           </a:ln>
           <a:effectLst/>
@@ -17959,7 +18003,7 @@
             <a:r>
               <a:rPr sz="1200" b="1">
                 <a:solidFill>
-                  <a:srgbClr val="0B1F3A"/>
+                  <a:srgbClr val="111418"/>
                 </a:solidFill>
                 <a:latin typeface="Calibri"/>
               </a:rPr>
@@ -18022,7 +18066,7 @@
             <a:avLst/>
           </a:prstGeom>
           <a:solidFill>
-            <a:srgbClr val="E2E8F0"/>
+            <a:srgbClr val="E3E6EB"/>
           </a:solidFill>
           <a:ln>
             <a:noFill/>
@@ -18081,7 +18125,7 @@
             <a:r>
               <a:rPr sz="1200" b="1">
                 <a:solidFill>
-                  <a:srgbClr val="0B1F3A"/>
+                  <a:srgbClr val="111418"/>
                 </a:solidFill>
                 <a:latin typeface="Calibri"/>
               </a:rPr>
@@ -18144,7 +18188,7 @@
             <a:avLst/>
           </a:prstGeom>
           <a:solidFill>
-            <a:srgbClr val="E2E8F0"/>
+            <a:srgbClr val="E3E6EB"/>
           </a:solidFill>
           <a:ln>
             <a:noFill/>
@@ -18203,7 +18247,7 @@
             <a:r>
               <a:rPr sz="1200" b="1">
                 <a:solidFill>
-                  <a:srgbClr val="0B1F3A"/>
+                  <a:srgbClr val="111418"/>
                 </a:solidFill>
                 <a:latin typeface="Calibri"/>
               </a:rPr>
@@ -18266,7 +18310,7 @@
             <a:avLst/>
           </a:prstGeom>
           <a:solidFill>
-            <a:srgbClr val="E2E8F0"/>
+            <a:srgbClr val="E3E6EB"/>
           </a:solidFill>
           <a:ln>
             <a:noFill/>
@@ -18325,7 +18369,7 @@
             <a:r>
               <a:rPr sz="1200" b="1">
                 <a:solidFill>
-                  <a:srgbClr val="0B1F3A"/>
+                  <a:srgbClr val="111418"/>
                 </a:solidFill>
                 <a:latin typeface="Calibri"/>
               </a:rPr>
@@ -18388,7 +18432,7 @@
             <a:avLst/>
           </a:prstGeom>
           <a:solidFill>
-            <a:srgbClr val="E2E8F0"/>
+            <a:srgbClr val="E3E6EB"/>
           </a:solidFill>
           <a:ln>
             <a:noFill/>
@@ -18447,7 +18491,7 @@
             <a:r>
               <a:rPr sz="1200" b="1">
                 <a:solidFill>
-                  <a:srgbClr val="0B1F3A"/>
+                  <a:srgbClr val="111418"/>
                 </a:solidFill>
                 <a:latin typeface="Calibri"/>
               </a:rPr>
@@ -18569,7 +18613,7 @@
             <a:r>
               <a:rPr sz="900" b="1">
                 <a:solidFill>
-                  <a:srgbClr val="6D28D9"/>
+                  <a:srgbClr val="F26522"/>
                 </a:solidFill>
                 <a:latin typeface="Calibri"/>
               </a:rPr>
@@ -18595,11 +18639,11 @@
             </a:avLst>
           </a:prstGeom>
           <a:solidFill>
-            <a:srgbClr val="F7F9FC"/>
+            <a:srgbClr val="F7F7F8"/>
           </a:solidFill>
           <a:ln>
             <a:solidFill>
-              <a:srgbClr val="E2E8F0"/>
+              <a:srgbClr val="E3E6EB"/>
             </a:solidFill>
           </a:ln>
           <a:effectLst/>
@@ -18656,7 +18700,7 @@
             <a:r>
               <a:rPr sz="1200" b="1">
                 <a:solidFill>
-                  <a:srgbClr val="0B1F3A"/>
+                  <a:srgbClr val="111418"/>
                 </a:solidFill>
                 <a:latin typeface="Calibri"/>
               </a:rPr>
@@ -18721,11 +18765,11 @@
             </a:avLst>
           </a:prstGeom>
           <a:solidFill>
-            <a:srgbClr val="EDE9FE"/>
+            <a:srgbClr val="FFECDF"/>
           </a:solidFill>
           <a:ln>
             <a:solidFill>
-              <a:srgbClr val="6D28D9"/>
+              <a:srgbClr val="F26522"/>
             </a:solidFill>
           </a:ln>
           <a:effectLst/>
@@ -18782,7 +18826,7 @@
             <a:r>
               <a:rPr sz="1200" b="1">
                 <a:solidFill>
-                  <a:srgbClr val="6D28D9"/>
+                  <a:srgbClr val="F26522"/>
                 </a:solidFill>
                 <a:latin typeface="Calibri"/>
               </a:rPr>
@@ -18821,7 +18865,7 @@
             <a:r>
               <a:rPr sz="1000" b="0">
                 <a:solidFill>
-                  <a:srgbClr val="0B1F3A"/>
+                  <a:srgbClr val="111418"/>
                 </a:solidFill>
                 <a:latin typeface="Calibri"/>
               </a:rPr>
@@ -18904,7 +18948,7 @@
             <a:r>
               <a:rPr sz="900" b="1">
                 <a:solidFill>
-                  <a:srgbClr val="6D28D9"/>
+                  <a:srgbClr val="F26522"/>
                 </a:solidFill>
                 <a:latin typeface="Calibri"/>
               </a:rPr>
@@ -18930,7 +18974,7 @@
             </a:avLst>
           </a:prstGeom>
           <a:solidFill>
-            <a:srgbClr val="0B1F3A"/>
+            <a:srgbClr val="111418"/>
           </a:solidFill>
           <a:ln>
             <a:noFill/>
@@ -19265,7 +19309,7 @@
             <a:avLst/>
           </a:prstGeom>
           <a:solidFill>
-            <a:srgbClr val="6D28D9"/>
+            <a:srgbClr val="F26522"/>
           </a:solidFill>
           <a:ln>
             <a:noFill/>
@@ -19324,7 +19368,7 @@
             <a:r>
               <a:rPr sz="1000" b="1">
                 <a:solidFill>
-                  <a:srgbClr val="6D28D9"/>
+                  <a:srgbClr val="F26522"/>
                 </a:solidFill>
                 <a:latin typeface="Calibri"/>
               </a:rPr>
@@ -19363,7 +19407,7 @@
             <a:r>
               <a:rPr sz="2600" b="1">
                 <a:solidFill>
-                  <a:srgbClr val="0B1F3A"/>
+                  <a:srgbClr val="111418"/>
                 </a:solidFill>
                 <a:latin typeface="Calibri"/>
               </a:rPr>
@@ -19387,7 +19431,7 @@
             <a:avLst/>
           </a:prstGeom>
           <a:solidFill>
-            <a:srgbClr val="0B1F3A"/>
+            <a:srgbClr val="111418"/>
           </a:solidFill>
           <a:ln>
             <a:noFill/>
@@ -19511,11 +19555,11 @@
             </a:avLst>
           </a:prstGeom>
           <a:solidFill>
-            <a:srgbClr val="F7F9FC"/>
+            <a:srgbClr val="F7F7F8"/>
           </a:solidFill>
           <a:ln w="9525">
             <a:solidFill>
-              <a:srgbClr val="E2E8F0"/>
+              <a:srgbClr val="E3E6EB"/>
             </a:solidFill>
           </a:ln>
           <a:effectLst/>
@@ -19559,7 +19603,7 @@
             </a:avLst>
           </a:prstGeom>
           <a:solidFill>
-            <a:srgbClr val="EDE9FE"/>
+            <a:srgbClr val="FFECDF"/>
           </a:solidFill>
           <a:ln>
             <a:noFill/>
@@ -19618,7 +19662,7 @@
             <a:r>
               <a:rPr sz="900" b="1">
                 <a:solidFill>
-                  <a:srgbClr val="6D28D9"/>
+                  <a:srgbClr val="F26522"/>
                 </a:solidFill>
                 <a:latin typeface="Calibri"/>
               </a:rPr>
@@ -19657,7 +19701,7 @@
             <a:r>
               <a:rPr sz="1500" b="1">
                 <a:solidFill>
-                  <a:srgbClr val="0B1F3A"/>
+                  <a:srgbClr val="111418"/>
                 </a:solidFill>
                 <a:latin typeface="Calibri"/>
               </a:rPr>
@@ -19699,7 +19743,7 @@
             <a:r>
               <a:rPr sz="1100" b="1">
                 <a:solidFill>
-                  <a:srgbClr val="6D28D9"/>
+                  <a:srgbClr val="F26522"/>
                 </a:solidFill>
                 <a:latin typeface="Calibri"/>
               </a:rPr>
@@ -19708,7 +19752,7 @@
             <a:r>
               <a:rPr sz="1100">
                 <a:solidFill>
-                  <a:srgbClr val="1F2937"/>
+                  <a:srgbClr val="1F242C"/>
                 </a:solidFill>
                 <a:latin typeface="Calibri"/>
               </a:rPr>
@@ -19727,7 +19771,7 @@
             <a:r>
               <a:rPr sz="1100" b="1">
                 <a:solidFill>
-                  <a:srgbClr val="6D28D9"/>
+                  <a:srgbClr val="F26522"/>
                 </a:solidFill>
                 <a:latin typeface="Calibri"/>
               </a:rPr>
@@ -19736,7 +19780,7 @@
             <a:r>
               <a:rPr sz="1100">
                 <a:solidFill>
-                  <a:srgbClr val="1F2937"/>
+                  <a:srgbClr val="1F242C"/>
                 </a:solidFill>
                 <a:latin typeface="Calibri"/>
               </a:rPr>
@@ -19755,7 +19799,7 @@
             <a:r>
               <a:rPr sz="1100" b="1">
                 <a:solidFill>
-                  <a:srgbClr val="6D28D9"/>
+                  <a:srgbClr val="F26522"/>
                 </a:solidFill>
                 <a:latin typeface="Calibri"/>
               </a:rPr>
@@ -19764,7 +19808,7 @@
             <a:r>
               <a:rPr sz="1100">
                 <a:solidFill>
-                  <a:srgbClr val="1F2937"/>
+                  <a:srgbClr val="1F242C"/>
                 </a:solidFill>
                 <a:latin typeface="Calibri"/>
               </a:rPr>
@@ -19783,7 +19827,7 @@
             <a:r>
               <a:rPr sz="1100" b="1">
                 <a:solidFill>
-                  <a:srgbClr val="6D28D9"/>
+                  <a:srgbClr val="F26522"/>
                 </a:solidFill>
                 <a:latin typeface="Calibri"/>
               </a:rPr>
@@ -19792,7 +19836,7 @@
             <a:r>
               <a:rPr sz="1100">
                 <a:solidFill>
-                  <a:srgbClr val="1F2937"/>
+                  <a:srgbClr val="1F242C"/>
                 </a:solidFill>
                 <a:latin typeface="Calibri"/>
               </a:rPr>
@@ -19811,7 +19855,7 @@
             <a:r>
               <a:rPr sz="1100" b="1">
                 <a:solidFill>
-                  <a:srgbClr val="6D28D9"/>
+                  <a:srgbClr val="F26522"/>
                 </a:solidFill>
                 <a:latin typeface="Calibri"/>
               </a:rPr>
@@ -19820,7 +19864,7 @@
             <a:r>
               <a:rPr sz="1100">
                 <a:solidFill>
-                  <a:srgbClr val="1F2937"/>
+                  <a:srgbClr val="1F242C"/>
                 </a:solidFill>
                 <a:latin typeface="Calibri"/>
               </a:rPr>
@@ -19846,11 +19890,11 @@
             </a:avLst>
           </a:prstGeom>
           <a:solidFill>
-            <a:srgbClr val="F7F9FC"/>
+            <a:srgbClr val="F7F7F8"/>
           </a:solidFill>
           <a:ln w="9525">
             <a:solidFill>
-              <a:srgbClr val="E2E8F0"/>
+              <a:srgbClr val="E3E6EB"/>
             </a:solidFill>
           </a:ln>
           <a:effectLst/>
@@ -19894,7 +19938,7 @@
             </a:avLst>
           </a:prstGeom>
           <a:solidFill>
-            <a:srgbClr val="EDE9FE"/>
+            <a:srgbClr val="FFECDF"/>
           </a:solidFill>
           <a:ln>
             <a:noFill/>
@@ -19953,7 +19997,7 @@
             <a:r>
               <a:rPr sz="900" b="1">
                 <a:solidFill>
-                  <a:srgbClr val="6D28D9"/>
+                  <a:srgbClr val="F26522"/>
                 </a:solidFill>
                 <a:latin typeface="Calibri"/>
               </a:rPr>
@@ -19992,7 +20036,7 @@
             <a:r>
               <a:rPr sz="1500" b="1">
                 <a:solidFill>
-                  <a:srgbClr val="0B1F3A"/>
+                  <a:srgbClr val="111418"/>
                 </a:solidFill>
                 <a:latin typeface="Calibri"/>
               </a:rPr>
@@ -20034,7 +20078,7 @@
             <a:r>
               <a:rPr sz="1100" b="1">
                 <a:solidFill>
-                  <a:srgbClr val="6D28D9"/>
+                  <a:srgbClr val="F26522"/>
                 </a:solidFill>
                 <a:latin typeface="Calibri"/>
               </a:rPr>
@@ -20043,7 +20087,7 @@
             <a:r>
               <a:rPr sz="1100">
                 <a:solidFill>
-                  <a:srgbClr val="1F2937"/>
+                  <a:srgbClr val="1F242C"/>
                 </a:solidFill>
                 <a:latin typeface="Calibri"/>
               </a:rPr>
@@ -20062,7 +20106,7 @@
             <a:r>
               <a:rPr sz="1100" b="1">
                 <a:solidFill>
-                  <a:srgbClr val="6D28D9"/>
+                  <a:srgbClr val="F26522"/>
                 </a:solidFill>
                 <a:latin typeface="Calibri"/>
               </a:rPr>
@@ -20071,7 +20115,7 @@
             <a:r>
               <a:rPr sz="1100">
                 <a:solidFill>
-                  <a:srgbClr val="1F2937"/>
+                  <a:srgbClr val="1F242C"/>
                 </a:solidFill>
                 <a:latin typeface="Calibri"/>
               </a:rPr>
@@ -20090,7 +20134,7 @@
             <a:r>
               <a:rPr sz="1100" b="1">
                 <a:solidFill>
-                  <a:srgbClr val="6D28D9"/>
+                  <a:srgbClr val="F26522"/>
                 </a:solidFill>
                 <a:latin typeface="Calibri"/>
               </a:rPr>
@@ -20099,7 +20143,7 @@
             <a:r>
               <a:rPr sz="1100">
                 <a:solidFill>
-                  <a:srgbClr val="1F2937"/>
+                  <a:srgbClr val="1F242C"/>
                 </a:solidFill>
                 <a:latin typeface="Calibri"/>
               </a:rPr>
@@ -20118,7 +20162,7 @@
             <a:r>
               <a:rPr sz="1100" b="1">
                 <a:solidFill>
-                  <a:srgbClr val="6D28D9"/>
+                  <a:srgbClr val="F26522"/>
                 </a:solidFill>
                 <a:latin typeface="Calibri"/>
               </a:rPr>
@@ -20127,7 +20171,7 @@
             <a:r>
               <a:rPr sz="1100">
                 <a:solidFill>
-                  <a:srgbClr val="1F2937"/>
+                  <a:srgbClr val="1F242C"/>
                 </a:solidFill>
                 <a:latin typeface="Calibri"/>
               </a:rPr>
@@ -20169,7 +20213,7 @@
             <a:avLst/>
           </a:prstGeom>
           <a:solidFill>
-            <a:srgbClr val="6D28D9"/>
+            <a:srgbClr val="F26522"/>
           </a:solidFill>
           <a:ln>
             <a:noFill/>
@@ -20228,7 +20272,7 @@
             <a:r>
               <a:rPr sz="1000" b="1">
                 <a:solidFill>
-                  <a:srgbClr val="6D28D9"/>
+                  <a:srgbClr val="F26522"/>
                 </a:solidFill>
                 <a:latin typeface="Calibri"/>
               </a:rPr>
@@ -20267,7 +20311,7 @@
             <a:r>
               <a:rPr sz="2600" b="1">
                 <a:solidFill>
-                  <a:srgbClr val="0B1F3A"/>
+                  <a:srgbClr val="111418"/>
                 </a:solidFill>
                 <a:latin typeface="Calibri"/>
               </a:rPr>
@@ -20291,7 +20335,7 @@
             <a:avLst/>
           </a:prstGeom>
           <a:solidFill>
-            <a:srgbClr val="0B1F3A"/>
+            <a:srgbClr val="111418"/>
           </a:solidFill>
           <a:ln>
             <a:noFill/>
@@ -20415,11 +20459,11 @@
             </a:avLst>
           </a:prstGeom>
           <a:solidFill>
-            <a:srgbClr val="F7F9FC"/>
+            <a:srgbClr val="F7F7F8"/>
           </a:solidFill>
           <a:ln w="9525">
             <a:solidFill>
-              <a:srgbClr val="E2E8F0"/>
+              <a:srgbClr val="E3E6EB"/>
             </a:solidFill>
           </a:ln>
           <a:effectLst/>
@@ -20463,7 +20507,7 @@
             </a:avLst>
           </a:prstGeom>
           <a:solidFill>
-            <a:srgbClr val="EDE9FE"/>
+            <a:srgbClr val="FFECDF"/>
           </a:solidFill>
           <a:ln>
             <a:noFill/>
@@ -20522,7 +20566,7 @@
             <a:r>
               <a:rPr sz="900" b="1">
                 <a:solidFill>
-                  <a:srgbClr val="6D28D9"/>
+                  <a:srgbClr val="F26522"/>
                 </a:solidFill>
                 <a:latin typeface="Calibri"/>
               </a:rPr>
@@ -20561,7 +20605,7 @@
             <a:r>
               <a:rPr sz="1500" b="1">
                 <a:solidFill>
-                  <a:srgbClr val="0B1F3A"/>
+                  <a:srgbClr val="111418"/>
                 </a:solidFill>
                 <a:latin typeface="Calibri"/>
               </a:rPr>
@@ -20603,7 +20647,7 @@
             <a:r>
               <a:rPr sz="1100" b="1">
                 <a:solidFill>
-                  <a:srgbClr val="6D28D9"/>
+                  <a:srgbClr val="F26522"/>
                 </a:solidFill>
                 <a:latin typeface="Calibri"/>
               </a:rPr>
@@ -20612,7 +20656,7 @@
             <a:r>
               <a:rPr sz="1100">
                 <a:solidFill>
-                  <a:srgbClr val="1F2937"/>
+                  <a:srgbClr val="1F242C"/>
                 </a:solidFill>
                 <a:latin typeface="Calibri"/>
               </a:rPr>
@@ -20631,7 +20675,7 @@
             <a:r>
               <a:rPr sz="1100" b="1">
                 <a:solidFill>
-                  <a:srgbClr val="6D28D9"/>
+                  <a:srgbClr val="F26522"/>
                 </a:solidFill>
                 <a:latin typeface="Calibri"/>
               </a:rPr>
@@ -20640,7 +20684,7 @@
             <a:r>
               <a:rPr sz="1100">
                 <a:solidFill>
-                  <a:srgbClr val="1F2937"/>
+                  <a:srgbClr val="1F242C"/>
                 </a:solidFill>
                 <a:latin typeface="Calibri"/>
               </a:rPr>
@@ -20659,7 +20703,7 @@
             <a:r>
               <a:rPr sz="1100" b="1">
                 <a:solidFill>
-                  <a:srgbClr val="6D28D9"/>
+                  <a:srgbClr val="F26522"/>
                 </a:solidFill>
                 <a:latin typeface="Calibri"/>
               </a:rPr>
@@ -20668,7 +20712,7 @@
             <a:r>
               <a:rPr sz="1100">
                 <a:solidFill>
-                  <a:srgbClr val="1F2937"/>
+                  <a:srgbClr val="1F242C"/>
                 </a:solidFill>
                 <a:latin typeface="Calibri"/>
               </a:rPr>
@@ -20687,7 +20731,7 @@
             <a:r>
               <a:rPr sz="1100" b="1">
                 <a:solidFill>
-                  <a:srgbClr val="6D28D9"/>
+                  <a:srgbClr val="F26522"/>
                 </a:solidFill>
                 <a:latin typeface="Calibri"/>
               </a:rPr>
@@ -20696,7 +20740,7 @@
             <a:r>
               <a:rPr sz="1100">
                 <a:solidFill>
-                  <a:srgbClr val="1F2937"/>
+                  <a:srgbClr val="1F242C"/>
                 </a:solidFill>
                 <a:latin typeface="Calibri"/>
               </a:rPr>
@@ -20715,7 +20759,7 @@
             <a:r>
               <a:rPr sz="1100" b="1">
                 <a:solidFill>
-                  <a:srgbClr val="6D28D9"/>
+                  <a:srgbClr val="F26522"/>
                 </a:solidFill>
                 <a:latin typeface="Calibri"/>
               </a:rPr>
@@ -20724,7 +20768,7 @@
             <a:r>
               <a:rPr sz="1100">
                 <a:solidFill>
-                  <a:srgbClr val="1F2937"/>
+                  <a:srgbClr val="1F242C"/>
                 </a:solidFill>
                 <a:latin typeface="Calibri"/>
               </a:rPr>
@@ -20750,11 +20794,11 @@
             </a:avLst>
           </a:prstGeom>
           <a:solidFill>
-            <a:srgbClr val="F7F9FC"/>
+            <a:srgbClr val="F7F7F8"/>
           </a:solidFill>
           <a:ln w="9525">
             <a:solidFill>
-              <a:srgbClr val="E2E8F0"/>
+              <a:srgbClr val="E3E6EB"/>
             </a:solidFill>
           </a:ln>
           <a:effectLst/>
@@ -20798,7 +20842,7 @@
             </a:avLst>
           </a:prstGeom>
           <a:solidFill>
-            <a:srgbClr val="EDE9FE"/>
+            <a:srgbClr val="FFECDF"/>
           </a:solidFill>
           <a:ln>
             <a:noFill/>
@@ -20857,7 +20901,7 @@
             <a:r>
               <a:rPr sz="900" b="1">
                 <a:solidFill>
-                  <a:srgbClr val="6D28D9"/>
+                  <a:srgbClr val="F26522"/>
                 </a:solidFill>
                 <a:latin typeface="Calibri"/>
               </a:rPr>
@@ -20896,7 +20940,7 @@
             <a:r>
               <a:rPr sz="1500" b="1">
                 <a:solidFill>
-                  <a:srgbClr val="0B1F3A"/>
+                  <a:srgbClr val="111418"/>
                 </a:solidFill>
                 <a:latin typeface="Calibri"/>
               </a:rPr>
@@ -20938,7 +20982,7 @@
             <a:r>
               <a:rPr sz="1100" b="1">
                 <a:solidFill>
-                  <a:srgbClr val="6D28D9"/>
+                  <a:srgbClr val="F26522"/>
                 </a:solidFill>
                 <a:latin typeface="Calibri"/>
               </a:rPr>
@@ -20947,7 +20991,7 @@
             <a:r>
               <a:rPr sz="1100">
                 <a:solidFill>
-                  <a:srgbClr val="1F2937"/>
+                  <a:srgbClr val="1F242C"/>
                 </a:solidFill>
                 <a:latin typeface="Calibri"/>
               </a:rPr>
@@ -20966,7 +21010,7 @@
             <a:r>
               <a:rPr sz="1100" b="1">
                 <a:solidFill>
-                  <a:srgbClr val="6D28D9"/>
+                  <a:srgbClr val="F26522"/>
                 </a:solidFill>
                 <a:latin typeface="Calibri"/>
               </a:rPr>
@@ -20975,7 +21019,7 @@
             <a:r>
               <a:rPr sz="1100">
                 <a:solidFill>
-                  <a:srgbClr val="1F2937"/>
+                  <a:srgbClr val="1F242C"/>
                 </a:solidFill>
                 <a:latin typeface="Calibri"/>
               </a:rPr>
@@ -20994,7 +21038,7 @@
             <a:r>
               <a:rPr sz="1100" b="1">
                 <a:solidFill>
-                  <a:srgbClr val="6D28D9"/>
+                  <a:srgbClr val="F26522"/>
                 </a:solidFill>
                 <a:latin typeface="Calibri"/>
               </a:rPr>
@@ -21003,7 +21047,7 @@
             <a:r>
               <a:rPr sz="1100">
                 <a:solidFill>
-                  <a:srgbClr val="1F2937"/>
+                  <a:srgbClr val="1F242C"/>
                 </a:solidFill>
                 <a:latin typeface="Calibri"/>
               </a:rPr>
@@ -21022,7 +21066,7 @@
             <a:r>
               <a:rPr sz="1100" b="1">
                 <a:solidFill>
-                  <a:srgbClr val="6D28D9"/>
+                  <a:srgbClr val="F26522"/>
                 </a:solidFill>
                 <a:latin typeface="Calibri"/>
               </a:rPr>
@@ -21031,7 +21075,7 @@
             <a:r>
               <a:rPr sz="1100">
                 <a:solidFill>
-                  <a:srgbClr val="1F2937"/>
+                  <a:srgbClr val="1F242C"/>
                 </a:solidFill>
                 <a:latin typeface="Calibri"/>
               </a:rPr>

</xml_diff>